<commit_message>
fix: bug and ppt
</commit_message>
<xml_diff>
--- a/PPT - Marquee Console Submission - [Actual Submission].pptx
+++ b/PPT - Marquee Console Submission - [Actual Submission].pptx
@@ -1743,7 +1743,7 @@
           </a:bodyPr>
           <a:lstStyle/>
           <a:p>
-            <a:pPr marL="285750" indent="-285750">
+            <a:pPr marL="285750" indent="-285750" algn="just">
               <a:buFont typeface="Arial" panose="020B0604020202020204" pitchFamily="34" charset="0"/>
               <a:buChar char="•"/>
               <a:defRPr sz="1725" b="0">
@@ -1756,6 +1756,17 @@
               </a:defRPr>
             </a:pPr>
             <a:r>
+              <a:rPr lang="en-US" sz="1725" dirty="0">
+                <a:solidFill>
+                  <a:srgbClr val="202020"/>
+                </a:solidFill>
+                <a:latin typeface="Arial"/>
+                <a:ea typeface="Arial"/>
+                <a:cs typeface="Arial"/>
+              </a:rPr>
+              <a:t>The UI fills the whole console window ( </a:t>
+            </a:r>
+            <a:r>
               <a:rPr lang="en-US" sz="1725" b="1" i="1" dirty="0" err="1">
                 <a:solidFill>
                   <a:srgbClr val="202020"/>
@@ -1767,19 +1778,30 @@
               <a:t>getConsoleSize</a:t>
             </a:r>
             <a:r>
-              <a:rPr lang="en-US" sz="1725" dirty="0">
-                <a:solidFill>
-                  <a:srgbClr val="202020"/>
-                </a:solidFill>
-                <a:latin typeface="Arial"/>
-                <a:ea typeface="Arial"/>
-                <a:cs typeface="Arial"/>
-              </a:rPr>
-              <a:t> detects the available Windows console width and height.</a:t>
-            </a:r>
-          </a:p>
-          <a:p>
-            <a:pPr marL="285750" indent="-285750">
+              <a:rPr lang="en-US" sz="1725" b="1" i="1" dirty="0">
+                <a:solidFill>
+                  <a:srgbClr val="202020"/>
+                </a:solidFill>
+                <a:latin typeface="Arial"/>
+                <a:ea typeface="Arial"/>
+                <a:cs typeface="Arial"/>
+              </a:rPr>
+              <a:t>() </a:t>
+            </a:r>
+            <a:r>
+              <a:rPr lang="en-US" sz="1725" dirty="0">
+                <a:solidFill>
+                  <a:srgbClr val="202020"/>
+                </a:solidFill>
+                <a:latin typeface="Arial"/>
+                <a:ea typeface="Arial"/>
+                <a:cs typeface="Arial"/>
+              </a:rPr>
+              <a:t>).</a:t>
+            </a:r>
+          </a:p>
+          <a:p>
+            <a:pPr marL="285750" indent="-285750" algn="just">
               <a:buFont typeface="Arial" panose="020B0604020202020204" pitchFamily="34" charset="0"/>
               <a:buChar char="•"/>
               <a:defRPr sz="1725" b="0">
@@ -1792,30 +1814,19 @@
               </a:defRPr>
             </a:pPr>
             <a:r>
-              <a:rPr lang="en-US" sz="1725" b="1" i="1" dirty="0">
-                <a:solidFill>
-                  <a:srgbClr val="202020"/>
-                </a:solidFill>
-                <a:latin typeface="Arial"/>
-                <a:ea typeface="Arial"/>
-                <a:cs typeface="Arial"/>
-              </a:rPr>
-              <a:t>main() </a:t>
-            </a:r>
-            <a:r>
-              <a:rPr lang="en-US" sz="1725" dirty="0">
-                <a:solidFill>
-                  <a:srgbClr val="202020"/>
-                </a:solidFill>
-                <a:latin typeface="Arial"/>
-                <a:ea typeface="Arial"/>
-                <a:cs typeface="Arial"/>
-              </a:rPr>
-              <a:t>sets up the console, clears the screen, and hides the cursor.</a:t>
-            </a:r>
-          </a:p>
-          <a:p>
-            <a:pPr marL="285750" indent="-285750">
+              <a:rPr lang="en-US" sz="1725" dirty="0">
+                <a:solidFill>
+                  <a:srgbClr val="202020"/>
+                </a:solidFill>
+                <a:latin typeface="Arial"/>
+                <a:ea typeface="Arial"/>
+                <a:cs typeface="Arial"/>
+              </a:rPr>
+              <a:t>Layout from top to bottom: header, marquee area,  ====  separator, status line, prompt, output.</a:t>
+            </a:r>
+          </a:p>
+          <a:p>
+            <a:pPr marL="285750" indent="-285750" algn="just">
               <a:buFont typeface="Arial" panose="020B0604020202020204" pitchFamily="34" charset="0"/>
               <a:buChar char="•"/>
               <a:defRPr sz="1725" b="0">
@@ -1836,7 +1847,7 @@
                 <a:ea typeface="Arial"/>
                 <a:cs typeface="Arial"/>
               </a:rPr>
-              <a:t>buildFrame</a:t>
+              <a:t>updateConsoleLayout</a:t>
             </a:r>
             <a:r>
               <a:rPr lang="en-US" sz="1725" b="1" i="1" dirty="0">
@@ -1858,11 +1869,11 @@
                 <a:ea typeface="Arial"/>
                 <a:cs typeface="Arial"/>
               </a:rPr>
-              <a:t>creates a blank text grid for every frame.</a:t>
-            </a:r>
-          </a:p>
-          <a:p>
-            <a:pPr marL="285750" indent="-285750">
+              <a:t>recalculates the areas and keeps the marquee inside them.</a:t>
+            </a:r>
+          </a:p>
+          <a:p>
+            <a:pPr marL="285750" indent="-285750" algn="just">
               <a:buFont typeface="Arial" panose="020B0604020202020204" pitchFamily="34" charset="0"/>
               <a:buChar char="•"/>
               <a:defRPr sz="1725" b="0">
@@ -1883,11 +1894,33 @@
                 <a:ea typeface="Arial"/>
                 <a:cs typeface="Arial"/>
               </a:rPr>
-              <a:t>The frame contains:</a:t>
-            </a:r>
-          </a:p>
-          <a:p>
-            <a:pPr marL="742950" lvl="1" indent="-285750">
+              <a:t>The window size is checked every 100 </a:t>
+            </a:r>
+            <a:r>
+              <a:rPr lang="en-US" sz="1725" dirty="0" err="1">
+                <a:solidFill>
+                  <a:srgbClr val="202020"/>
+                </a:solidFill>
+                <a:latin typeface="Arial"/>
+                <a:ea typeface="Arial"/>
+                <a:cs typeface="Arial"/>
+              </a:rPr>
+              <a:t>ms.</a:t>
+            </a:r>
+            <a:r>
+              <a:rPr lang="en-US" sz="1725" dirty="0">
+                <a:solidFill>
+                  <a:srgbClr val="202020"/>
+                </a:solidFill>
+                <a:latin typeface="Arial"/>
+                <a:ea typeface="Arial"/>
+                <a:cs typeface="Arial"/>
+              </a:rPr>
+              <a:t> On a resize, the screen is cleared and the layout is recalculated.</a:t>
+            </a:r>
+          </a:p>
+          <a:p>
+            <a:pPr marL="285750" indent="-285750" algn="just">
               <a:buFont typeface="Arial" panose="020B0604020202020204" pitchFamily="34" charset="0"/>
               <a:buChar char="•"/>
               <a:defRPr sz="1725" b="0">
@@ -1908,278 +1941,9 @@
                 <a:ea typeface="Arial"/>
                 <a:cs typeface="Arial"/>
               </a:rPr>
-              <a:t>Welcome and developer information</a:t>
-            </a:r>
-          </a:p>
-          <a:p>
-            <a:pPr marL="742950" lvl="1" indent="-285750">
-              <a:buFont typeface="Arial" panose="020B0604020202020204" pitchFamily="34" charset="0"/>
-              <a:buChar char="•"/>
-              <a:defRPr sz="1725" b="0">
-                <a:solidFill>
-                  <a:srgbClr val="202020"/>
-                </a:solidFill>
-                <a:latin typeface="Arial"/>
-                <a:ea typeface="Arial"/>
-                <a:cs typeface="Arial"/>
-              </a:defRPr>
-            </a:pPr>
-            <a:r>
-              <a:rPr lang="en-US" sz="1725" dirty="0">
-                <a:solidFill>
-                  <a:srgbClr val="202020"/>
-                </a:solidFill>
-                <a:latin typeface="Arial"/>
-                <a:ea typeface="Arial"/>
-                <a:cs typeface="Arial"/>
-              </a:rPr>
-              <a:t>Version date and title</a:t>
-            </a:r>
-          </a:p>
-          <a:p>
-            <a:pPr marL="742950" lvl="1" indent="-285750">
-              <a:buFont typeface="Arial" panose="020B0604020202020204" pitchFamily="34" charset="0"/>
-              <a:buChar char="•"/>
-              <a:defRPr sz="1725" b="0">
-                <a:solidFill>
-                  <a:srgbClr val="202020"/>
-                </a:solidFill>
-                <a:latin typeface="Arial"/>
-                <a:ea typeface="Arial"/>
-                <a:cs typeface="Arial"/>
-              </a:defRPr>
-            </a:pPr>
-            <a:r>
-              <a:rPr lang="en-US" sz="1725" dirty="0">
-                <a:solidFill>
-                  <a:srgbClr val="202020"/>
-                </a:solidFill>
-                <a:latin typeface="Arial"/>
-                <a:ea typeface="Arial"/>
-                <a:cs typeface="Arial"/>
-              </a:rPr>
-              <a:t>Moving marquee</a:t>
-            </a:r>
-          </a:p>
-          <a:p>
-            <a:pPr marL="742950" lvl="1" indent="-285750">
-              <a:buFont typeface="Arial" panose="020B0604020202020204" pitchFamily="34" charset="0"/>
-              <a:buChar char="•"/>
-              <a:defRPr sz="1725" b="0">
-                <a:solidFill>
-                  <a:srgbClr val="202020"/>
-                </a:solidFill>
-                <a:latin typeface="Arial"/>
-                <a:ea typeface="Arial"/>
-                <a:cs typeface="Arial"/>
-              </a:defRPr>
-            </a:pPr>
-            <a:r>
-              <a:rPr lang="en-US" sz="1725" dirty="0">
-                <a:solidFill>
-                  <a:srgbClr val="202020"/>
-                </a:solidFill>
-                <a:latin typeface="Arial"/>
-                <a:ea typeface="Arial"/>
-                <a:cs typeface="Arial"/>
-              </a:rPr>
-              <a:t>Bottom separator</a:t>
-            </a:r>
-          </a:p>
-          <a:p>
-            <a:pPr marL="742950" lvl="1" indent="-285750">
-              <a:buFont typeface="Arial" panose="020B0604020202020204" pitchFamily="34" charset="0"/>
-              <a:buChar char="•"/>
-              <a:defRPr sz="1725" b="0">
-                <a:solidFill>
-                  <a:srgbClr val="202020"/>
-                </a:solidFill>
-                <a:latin typeface="Arial"/>
-                <a:ea typeface="Arial"/>
-                <a:cs typeface="Arial"/>
-              </a:defRPr>
-            </a:pPr>
-            <a:r>
-              <a:rPr lang="en-US" sz="1725" dirty="0">
-                <a:solidFill>
-                  <a:srgbClr val="202020"/>
-                </a:solidFill>
-                <a:latin typeface="Arial"/>
-                <a:ea typeface="Arial"/>
-                <a:cs typeface="Arial"/>
-              </a:rPr>
-              <a:t>Refresh status</a:t>
-            </a:r>
-          </a:p>
-          <a:p>
-            <a:pPr marL="742950" lvl="1" indent="-285750">
-              <a:buFont typeface="Arial" panose="020B0604020202020204" pitchFamily="34" charset="0"/>
-              <a:buChar char="•"/>
-              <a:defRPr sz="1725" b="0">
-                <a:solidFill>
-                  <a:srgbClr val="202020"/>
-                </a:solidFill>
-                <a:latin typeface="Arial"/>
-                <a:ea typeface="Arial"/>
-                <a:cs typeface="Arial"/>
-              </a:defRPr>
-            </a:pPr>
-            <a:r>
-              <a:rPr lang="en-US" sz="1725" dirty="0">
-                <a:solidFill>
-                  <a:srgbClr val="202020"/>
-                </a:solidFill>
-                <a:latin typeface="Arial"/>
-                <a:ea typeface="Arial"/>
-                <a:cs typeface="Arial"/>
-              </a:rPr>
-              <a:t>Command prompt</a:t>
-            </a:r>
-          </a:p>
-          <a:p>
-            <a:pPr marL="742950" lvl="1" indent="-285750">
-              <a:buFont typeface="Arial" panose="020B0604020202020204" pitchFamily="34" charset="0"/>
-              <a:buChar char="•"/>
-              <a:defRPr sz="1725" b="0">
-                <a:solidFill>
-                  <a:srgbClr val="202020"/>
-                </a:solidFill>
-                <a:latin typeface="Arial"/>
-                <a:ea typeface="Arial"/>
-                <a:cs typeface="Arial"/>
-              </a:defRPr>
-            </a:pPr>
-            <a:r>
-              <a:rPr lang="en-US" sz="1725" dirty="0">
-                <a:solidFill>
-                  <a:srgbClr val="202020"/>
-                </a:solidFill>
-                <a:latin typeface="Arial"/>
-                <a:ea typeface="Arial"/>
-                <a:cs typeface="Arial"/>
-              </a:rPr>
-              <a:t>Command output</a:t>
-            </a:r>
-          </a:p>
-          <a:p>
-            <a:pPr marL="285750" indent="-285750">
-              <a:buFont typeface="Arial" panose="020B0604020202020204" pitchFamily="34" charset="0"/>
-              <a:buChar char="•"/>
-              <a:defRPr sz="1725" b="0">
-                <a:solidFill>
-                  <a:srgbClr val="202020"/>
-                </a:solidFill>
-                <a:latin typeface="Arial"/>
-                <a:ea typeface="Arial"/>
-                <a:cs typeface="Arial"/>
-              </a:defRPr>
-            </a:pPr>
-            <a:r>
-              <a:rPr lang="en-US" sz="1725" b="1" i="1" dirty="0" err="1">
-                <a:solidFill>
-                  <a:srgbClr val="202020"/>
-                </a:solidFill>
-                <a:latin typeface="Arial"/>
-                <a:ea typeface="Arial"/>
-                <a:cs typeface="Arial"/>
-              </a:rPr>
-              <a:t>putStr</a:t>
-            </a:r>
-            <a:r>
-              <a:rPr lang="en-US" sz="1725" b="1" i="1" dirty="0">
-                <a:solidFill>
-                  <a:srgbClr val="202020"/>
-                </a:solidFill>
-                <a:latin typeface="Arial"/>
-                <a:ea typeface="Arial"/>
-                <a:cs typeface="Arial"/>
-              </a:rPr>
-              <a:t>() </a:t>
-            </a:r>
-            <a:r>
-              <a:rPr lang="en-US" sz="1725" dirty="0">
-                <a:solidFill>
-                  <a:srgbClr val="202020"/>
-                </a:solidFill>
-                <a:latin typeface="Arial"/>
-                <a:ea typeface="Arial"/>
-                <a:cs typeface="Arial"/>
-              </a:rPr>
-              <a:t>places text at specific rows and columns.</a:t>
-            </a:r>
-          </a:p>
-          <a:p>
-            <a:pPr marL="285750" indent="-285750">
-              <a:buFont typeface="Arial" panose="020B0604020202020204" pitchFamily="34" charset="0"/>
-              <a:buChar char="•"/>
-              <a:defRPr sz="1725" b="0">
-                <a:solidFill>
-                  <a:srgbClr val="202020"/>
-                </a:solidFill>
-                <a:latin typeface="Arial"/>
-                <a:ea typeface="Arial"/>
-                <a:cs typeface="Arial"/>
-              </a:defRPr>
-            </a:pPr>
-            <a:r>
-              <a:rPr lang="en-US" sz="1725" b="1" i="1" dirty="0" err="1">
-                <a:solidFill>
-                  <a:srgbClr val="202020"/>
-                </a:solidFill>
-                <a:latin typeface="Arial"/>
-                <a:ea typeface="Arial"/>
-                <a:cs typeface="Arial"/>
-              </a:rPr>
-              <a:t>drawFrame</a:t>
-            </a:r>
-            <a:r>
-              <a:rPr lang="en-US" sz="1725" b="1" i="1" dirty="0">
-                <a:solidFill>
-                  <a:srgbClr val="202020"/>
-                </a:solidFill>
-                <a:latin typeface="Arial"/>
-                <a:ea typeface="Arial"/>
-                <a:cs typeface="Arial"/>
-              </a:rPr>
-              <a:t>() </a:t>
-            </a:r>
-            <a:r>
-              <a:rPr lang="en-US" sz="1725" dirty="0">
-                <a:solidFill>
-                  <a:srgbClr val="202020"/>
-                </a:solidFill>
-                <a:latin typeface="Arial"/>
-                <a:ea typeface="Arial"/>
-                <a:cs typeface="Arial"/>
-              </a:rPr>
-              <a:t>moves the cursor back to the top-left and redraws the frame without scrolling.</a:t>
-            </a:r>
-          </a:p>
-          <a:p>
-            <a:pPr marL="285750" indent="-285750">
-              <a:buFont typeface="Arial" panose="020B0604020202020204" pitchFamily="34" charset="0"/>
-              <a:buChar char="•"/>
-              <a:defRPr sz="1725" b="0">
-                <a:solidFill>
-                  <a:srgbClr val="202020"/>
-                </a:solidFill>
-                <a:latin typeface="Arial"/>
-                <a:ea typeface="Arial"/>
-                <a:cs typeface="Arial"/>
-              </a:defRPr>
-            </a:pPr>
-            <a:r>
-              <a:rPr lang="en-US" sz="1725" dirty="0">
-                <a:solidFill>
-                  <a:srgbClr val="202020"/>
-                </a:solidFill>
-                <a:latin typeface="Arial"/>
-                <a:ea typeface="Arial"/>
-                <a:cs typeface="Arial"/>
-              </a:rPr>
-              <a:t>The cursor is restored when the program exits.</a:t>
-            </a:r>
-            <a:endParaRPr sz="1725" b="0" dirty="0">
+              <a:t>The window must be at least 60×25. The cursor is hidden while running and restored on exit.</a:t>
+            </a:r>
+            <a:endParaRPr sz="1725" dirty="0">
               <a:solidFill>
                 <a:srgbClr val="202020"/>
               </a:solidFill>
@@ -2192,10 +1956,10 @@
       </p:sp>
       <p:pic>
         <p:nvPicPr>
-          <p:cNvPr id="11" name="Picture 10">
+          <p:cNvPr id="4" name="Picture 3">
             <a:extLst>
               <a:ext uri="{FF2B5EF4-FFF2-40B4-BE49-F238E27FC236}">
-                <a16:creationId xmlns:a16="http://schemas.microsoft.com/office/drawing/2014/main" id="{B32C9F03-4B8A-987E-ABEE-8EA537952F78}"/>
+                <a16:creationId xmlns:a16="http://schemas.microsoft.com/office/drawing/2014/main" id="{61C0FC1E-50A8-54EF-D0F8-42323F1281A5}"/>
               </a:ext>
             </a:extLst>
           </p:cNvPr>
@@ -2212,38 +1976,8 @@
         </p:blipFill>
         <p:spPr>
           <a:xfrm>
-            <a:off x="1936754" y="5118179"/>
-            <a:ext cx="3520319" cy="1263571"/>
-          </a:xfrm>
-          <a:prstGeom prst="rect">
-            <a:avLst/>
-          </a:prstGeom>
-        </p:spPr>
-      </p:pic>
-      <p:pic>
-        <p:nvPicPr>
-          <p:cNvPr id="13" name="Picture 12">
-            <a:extLst>
-              <a:ext uri="{FF2B5EF4-FFF2-40B4-BE49-F238E27FC236}">
-                <a16:creationId xmlns:a16="http://schemas.microsoft.com/office/drawing/2014/main" id="{60BC7B63-BBD7-A5E2-D9B2-8C359D9DF60F}"/>
-              </a:ext>
-            </a:extLst>
-          </p:cNvPr>
-          <p:cNvPicPr>
-            <a:picLocks noChangeAspect="1"/>
-          </p:cNvPicPr>
-          <p:nvPr/>
-        </p:nvPicPr>
-        <p:blipFill>
-          <a:blip r:embed="rId4"/>
-          <a:stretch>
-            <a:fillRect/>
-          </a:stretch>
-        </p:blipFill>
-        <p:spPr>
-          <a:xfrm>
-            <a:off x="5666232" y="5118179"/>
-            <a:ext cx="4808280" cy="1263571"/>
+            <a:off x="2848228" y="3156940"/>
+            <a:ext cx="6495544" cy="3057923"/>
           </a:xfrm>
           <a:prstGeom prst="rect">
             <a:avLst/>
@@ -2367,7 +2101,7 @@
         </p:nvSpPr>
         <p:spPr>
           <a:xfrm>
-            <a:off x="685800" y="1390650"/>
+            <a:off x="685800" y="1299210"/>
             <a:ext cx="10820400" cy="885825"/>
           </a:xfrm>
           <a:prstGeom prst="rect">
@@ -2384,7 +2118,7 @@
           </a:bodyPr>
           <a:lstStyle/>
           <a:p>
-            <a:pPr marL="285750" indent="-285750">
+            <a:pPr marL="285750" indent="-285750" algn="just">
               <a:buFont typeface="Arial" panose="020B0604020202020204" pitchFamily="34" charset="0"/>
               <a:buChar char="•"/>
               <a:defRPr sz="1725" b="0">
@@ -2416,6 +2150,50 @@
                 <a:ea typeface="Arial"/>
                 <a:cs typeface="Arial"/>
               </a:rPr>
+              <a:t>() </a:t>
+            </a:r>
+            <a:r>
+              <a:rPr lang="en-US" sz="1725" dirty="0">
+                <a:solidFill>
+                  <a:srgbClr val="202020"/>
+                </a:solidFill>
+                <a:latin typeface="Arial"/>
+                <a:ea typeface="Arial"/>
+                <a:cs typeface="Arial"/>
+              </a:rPr>
+              <a:t>reads keys with </a:t>
+            </a:r>
+            <a:r>
+              <a:rPr lang="en-US" sz="1725" b="1" i="1" dirty="0">
+                <a:solidFill>
+                  <a:srgbClr val="202020"/>
+                </a:solidFill>
+                <a:latin typeface="Arial"/>
+                <a:ea typeface="Arial"/>
+                <a:cs typeface="Arial"/>
+              </a:rPr>
+              <a:t>_</a:t>
+            </a:r>
+            <a:r>
+              <a:rPr lang="en-US" sz="1725" b="1" i="1" dirty="0" err="1">
+                <a:solidFill>
+                  <a:srgbClr val="202020"/>
+                </a:solidFill>
+                <a:latin typeface="Arial"/>
+                <a:ea typeface="Arial"/>
+                <a:cs typeface="Arial"/>
+              </a:rPr>
+              <a:t>kbhit</a:t>
+            </a:r>
+            <a:r>
+              <a:rPr lang="en-US" sz="1725" b="1" i="1" dirty="0">
+                <a:solidFill>
+                  <a:srgbClr val="202020"/>
+                </a:solidFill>
+                <a:latin typeface="Arial"/>
+                <a:ea typeface="Arial"/>
+                <a:cs typeface="Arial"/>
+              </a:rPr>
               <a:t>() </a:t>
             </a:r>
             <a:r>
@@ -2427,11 +2205,55 @@
                 <a:ea typeface="Arial"/>
                 <a:cs typeface="Arial"/>
               </a:rPr>
-              <a:t>checks for keyboard input without stopping the animation.</a:t>
-            </a:r>
-          </a:p>
-          <a:p>
-            <a:pPr marL="285750" indent="-285750">
+              <a:t>and </a:t>
+            </a:r>
+            <a:r>
+              <a:rPr lang="en-US" sz="1725" b="1" i="1" dirty="0">
+                <a:solidFill>
+                  <a:srgbClr val="202020"/>
+                </a:solidFill>
+                <a:latin typeface="Arial"/>
+                <a:ea typeface="Arial"/>
+                <a:cs typeface="Arial"/>
+              </a:rPr>
+              <a:t>_</a:t>
+            </a:r>
+            <a:r>
+              <a:rPr lang="en-US" sz="1725" b="1" i="1" dirty="0" err="1">
+                <a:solidFill>
+                  <a:srgbClr val="202020"/>
+                </a:solidFill>
+                <a:latin typeface="Arial"/>
+                <a:ea typeface="Arial"/>
+                <a:cs typeface="Arial"/>
+              </a:rPr>
+              <a:t>getch</a:t>
+            </a:r>
+            <a:r>
+              <a:rPr lang="en-US" sz="1725" b="1" i="1" dirty="0">
+                <a:solidFill>
+                  <a:srgbClr val="202020"/>
+                </a:solidFill>
+                <a:latin typeface="Arial"/>
+                <a:ea typeface="Arial"/>
+                <a:cs typeface="Arial"/>
+              </a:rPr>
+              <a:t>() </a:t>
+            </a:r>
+            <a:r>
+              <a:rPr lang="en-US" sz="1725" dirty="0">
+                <a:solidFill>
+                  <a:srgbClr val="202020"/>
+                </a:solidFill>
+                <a:latin typeface="Arial"/>
+                <a:ea typeface="Arial"/>
+                <a:cs typeface="Arial"/>
+              </a:rPr>
+              <a:t>without blocking, so the animation never waits for typing.</a:t>
+            </a:r>
+          </a:p>
+          <a:p>
+            <a:pPr marL="285750" indent="-285750" algn="just">
               <a:buFont typeface="Arial" panose="020B0604020202020204" pitchFamily="34" charset="0"/>
               <a:buChar char="•"/>
               <a:defRPr sz="1725" b="0">
@@ -2444,96 +2266,19 @@
               </a:defRPr>
             </a:pPr>
             <a:r>
-              <a:rPr lang="en-US" sz="1725" b="1" i="1" dirty="0">
-                <a:solidFill>
-                  <a:srgbClr val="202020"/>
-                </a:solidFill>
-                <a:latin typeface="Arial"/>
-                <a:ea typeface="Arial"/>
-                <a:cs typeface="Arial"/>
-              </a:rPr>
-              <a:t>_</a:t>
-            </a:r>
-            <a:r>
-              <a:rPr lang="en-US" sz="1725" b="1" i="1" dirty="0" err="1">
-                <a:solidFill>
-                  <a:srgbClr val="202020"/>
-                </a:solidFill>
-                <a:latin typeface="Arial"/>
-                <a:ea typeface="Arial"/>
-                <a:cs typeface="Arial"/>
-              </a:rPr>
-              <a:t>kbhit</a:t>
-            </a:r>
-            <a:r>
-              <a:rPr lang="en-US" sz="1725" b="1" i="1" dirty="0">
-                <a:solidFill>
-                  <a:srgbClr val="202020"/>
-                </a:solidFill>
-                <a:latin typeface="Arial"/>
-                <a:ea typeface="Arial"/>
-                <a:cs typeface="Arial"/>
-              </a:rPr>
-              <a:t>() </a:t>
-            </a:r>
-            <a:r>
-              <a:rPr lang="en-US" sz="1725" dirty="0">
-                <a:solidFill>
-                  <a:srgbClr val="202020"/>
-                </a:solidFill>
-                <a:latin typeface="Arial"/>
-                <a:ea typeface="Arial"/>
-                <a:cs typeface="Arial"/>
-              </a:rPr>
-              <a:t>detects whether a key is available, while </a:t>
-            </a:r>
-            <a:r>
-              <a:rPr lang="en-US" sz="1725" b="1" i="1" dirty="0">
-                <a:solidFill>
-                  <a:srgbClr val="202020"/>
-                </a:solidFill>
-                <a:latin typeface="Arial"/>
-                <a:ea typeface="Arial"/>
-                <a:cs typeface="Arial"/>
-              </a:rPr>
-              <a:t>_</a:t>
-            </a:r>
-            <a:r>
-              <a:rPr lang="en-US" sz="1725" b="1" i="1" dirty="0" err="1">
-                <a:solidFill>
-                  <a:srgbClr val="202020"/>
-                </a:solidFill>
-                <a:latin typeface="Arial"/>
-                <a:ea typeface="Arial"/>
-                <a:cs typeface="Arial"/>
-              </a:rPr>
-              <a:t>getch</a:t>
-            </a:r>
-            <a:r>
-              <a:rPr lang="en-US" sz="1725" b="1" i="1" dirty="0">
-                <a:solidFill>
-                  <a:srgbClr val="202020"/>
-                </a:solidFill>
-                <a:latin typeface="Arial"/>
-                <a:ea typeface="Arial"/>
-                <a:cs typeface="Arial"/>
-              </a:rPr>
-              <a:t>()  </a:t>
-            </a:r>
-            <a:r>
-              <a:rPr lang="en-US" sz="1725" dirty="0">
-                <a:solidFill>
-                  <a:srgbClr val="202020"/>
-                </a:solidFill>
-                <a:latin typeface="Arial"/>
-                <a:ea typeface="Arial"/>
-                <a:cs typeface="Arial"/>
-              </a:rPr>
-              <a:t>reads it.</a:t>
-            </a:r>
-          </a:p>
-          <a:p>
-            <a:pPr marL="285750" indent="-285750">
+              <a:rPr lang="en-US" sz="1725" dirty="0">
+                <a:solidFill>
+                  <a:srgbClr val="202020"/>
+                </a:solidFill>
+                <a:latin typeface="Arial"/>
+                <a:ea typeface="Arial"/>
+                <a:cs typeface="Arial"/>
+              </a:rPr>
+              <a:t>Printable keys are added to the input, Backspace deletes, Enter submits, and arrow keys are ignored.</a:t>
+            </a:r>
+          </a:p>
+          <a:p>
+            <a:pPr marL="285750" indent="-285750" algn="just">
               <a:buFont typeface="Arial" panose="020B0604020202020204" pitchFamily="34" charset="0"/>
               <a:buChar char="•"/>
               <a:defRPr sz="1725" b="0">
@@ -2546,17 +2291,6 @@
               </a:defRPr>
             </a:pPr>
             <a:r>
-              <a:rPr lang="en-US" sz="1725" dirty="0">
-                <a:solidFill>
-                  <a:srgbClr val="202020"/>
-                </a:solidFill>
-                <a:latin typeface="Arial"/>
-                <a:ea typeface="Arial"/>
-                <a:cs typeface="Arial"/>
-              </a:rPr>
-              <a:t>Printable characters are added to </a:t>
-            </a:r>
-            <a:r>
               <a:rPr lang="en-US" sz="1725" b="1" i="1" dirty="0" err="1">
                 <a:solidFill>
                   <a:srgbClr val="202020"/>
@@ -2565,22 +2299,33 @@
                 <a:ea typeface="Arial"/>
                 <a:cs typeface="Arial"/>
               </a:rPr>
-              <a:t>currentInput</a:t>
-            </a:r>
-            <a:r>
-              <a:rPr lang="en-US" sz="1725" dirty="0">
-                <a:solidFill>
-                  <a:srgbClr val="202020"/>
-                </a:solidFill>
-                <a:latin typeface="Arial"/>
-                <a:ea typeface="Arial"/>
-                <a:cs typeface="Arial"/>
-              </a:rPr>
-              <a:t>.</a:t>
-            </a:r>
-          </a:p>
-          <a:p>
-            <a:pPr marL="285750" indent="-285750">
+              <a:t>submitCommand</a:t>
+            </a:r>
+            <a:r>
+              <a:rPr lang="en-US" sz="1725" b="1" i="1" dirty="0">
+                <a:solidFill>
+                  <a:srgbClr val="202020"/>
+                </a:solidFill>
+                <a:latin typeface="Arial"/>
+                <a:ea typeface="Arial"/>
+                <a:cs typeface="Arial"/>
+              </a:rPr>
+              <a:t>() </a:t>
+            </a:r>
+            <a:r>
+              <a:rPr lang="en-US" sz="1725" dirty="0">
+                <a:solidFill>
+                  <a:srgbClr val="202020"/>
+                </a:solidFill>
+                <a:latin typeface="Arial"/>
+                <a:ea typeface="Arial"/>
+                <a:cs typeface="Arial"/>
+              </a:rPr>
+              <a:t>trims the input, splits the command from its argument, lowercases the command, then runs it.</a:t>
+            </a:r>
+          </a:p>
+          <a:p>
+            <a:pPr marL="285750" indent="-285750" algn="just">
               <a:buFont typeface="Arial" panose="020B0604020202020204" pitchFamily="34" charset="0"/>
               <a:buChar char="•"/>
               <a:defRPr sz="1725" b="0">
@@ -2601,47 +2346,30 @@
                 <a:ea typeface="Arial"/>
                 <a:cs typeface="Arial"/>
               </a:rPr>
-              <a:t>Backspace removes the last character.</a:t>
-            </a:r>
-          </a:p>
-          <a:p>
-            <a:pPr marL="285750" indent="-285750">
-              <a:buFont typeface="Arial" panose="020B0604020202020204" pitchFamily="34" charset="0"/>
-              <a:buChar char="•"/>
-              <a:defRPr sz="1725" b="0">
-                <a:solidFill>
-                  <a:srgbClr val="202020"/>
-                </a:solidFill>
-                <a:latin typeface="Arial"/>
-                <a:ea typeface="Arial"/>
-                <a:cs typeface="Arial"/>
-              </a:defRPr>
-            </a:pPr>
-            <a:r>
-              <a:rPr lang="en-US" sz="1725" dirty="0">
-                <a:solidFill>
-                  <a:srgbClr val="202020"/>
-                </a:solidFill>
-                <a:latin typeface="Arial"/>
-                <a:ea typeface="Arial"/>
-                <a:cs typeface="Arial"/>
-              </a:rPr>
-              <a:t>Enter submits the command.</a:t>
-            </a:r>
-          </a:p>
-          <a:p>
-            <a:pPr marL="285750" indent="-285750">
-              <a:buFont typeface="Arial" panose="020B0604020202020204" pitchFamily="34" charset="0"/>
-              <a:buChar char="•"/>
-              <a:defRPr sz="1725" b="0">
-                <a:solidFill>
-                  <a:srgbClr val="202020"/>
-                </a:solidFill>
-                <a:latin typeface="Arial"/>
-                <a:ea typeface="Arial"/>
-                <a:cs typeface="Arial"/>
-              </a:defRPr>
-            </a:pPr>
+              <a:t>Unknown commands show an error, and wrong or extra arguments show a </a:t>
+            </a:r>
+            <a:r>
+              <a:rPr lang="en-US" sz="1725" b="1" i="1" dirty="0">
+                <a:solidFill>
+                  <a:srgbClr val="202020"/>
+                </a:solidFill>
+                <a:latin typeface="Arial"/>
+                <a:ea typeface="Arial"/>
+                <a:cs typeface="Arial"/>
+              </a:rPr>
+              <a:t>Usage: </a:t>
+            </a:r>
+            <a:r>
+              <a:rPr lang="en-US" sz="1725" dirty="0">
+                <a:solidFill>
+                  <a:srgbClr val="202020"/>
+                </a:solidFill>
+                <a:latin typeface="Arial"/>
+                <a:ea typeface="Arial"/>
+                <a:cs typeface="Arial"/>
+              </a:rPr>
+              <a:t>message. </a:t>
+            </a:r>
             <a:r>
               <a:rPr lang="en-US" sz="1725" b="1" i="1" dirty="0" err="1">
                 <a:solidFill>
@@ -2651,7 +2379,7 @@
                 <a:ea typeface="Arial"/>
                 <a:cs typeface="Arial"/>
               </a:rPr>
-              <a:t>submitCommand</a:t>
+              <a:t>set_speed</a:t>
             </a:r>
             <a:r>
               <a:rPr lang="en-US" sz="1725" b="1" i="1" dirty="0">
@@ -2662,300 +2390,6 @@
                 <a:ea typeface="Arial"/>
                 <a:cs typeface="Arial"/>
               </a:rPr>
-              <a:t>()</a:t>
-            </a:r>
-            <a:r>
-              <a:rPr lang="en-US" sz="1725" dirty="0">
-                <a:solidFill>
-                  <a:srgbClr val="202020"/>
-                </a:solidFill>
-                <a:latin typeface="Arial"/>
-                <a:ea typeface="Arial"/>
-                <a:cs typeface="Arial"/>
-              </a:rPr>
-              <a:t>:</a:t>
-            </a:r>
-          </a:p>
-          <a:p>
-            <a:pPr marL="742950" lvl="1" indent="-285750">
-              <a:buFont typeface="Arial" panose="020B0604020202020204" pitchFamily="34" charset="0"/>
-              <a:buChar char="•"/>
-              <a:defRPr sz="1725" b="0">
-                <a:solidFill>
-                  <a:srgbClr val="202020"/>
-                </a:solidFill>
-                <a:latin typeface="Arial"/>
-                <a:ea typeface="Arial"/>
-                <a:cs typeface="Arial"/>
-              </a:defRPr>
-            </a:pPr>
-            <a:r>
-              <a:rPr lang="en-US" sz="1725" dirty="0">
-                <a:solidFill>
-                  <a:srgbClr val="202020"/>
-                </a:solidFill>
-                <a:latin typeface="Arial"/>
-                <a:ea typeface="Arial"/>
-                <a:cs typeface="Arial"/>
-              </a:rPr>
-              <a:t>Removes unnecessary spaces</a:t>
-            </a:r>
-          </a:p>
-          <a:p>
-            <a:pPr marL="742950" lvl="1" indent="-285750">
-              <a:buFont typeface="Arial" panose="020B0604020202020204" pitchFamily="34" charset="0"/>
-              <a:buChar char="•"/>
-              <a:defRPr sz="1725" b="0">
-                <a:solidFill>
-                  <a:srgbClr val="202020"/>
-                </a:solidFill>
-                <a:latin typeface="Arial"/>
-                <a:ea typeface="Arial"/>
-                <a:cs typeface="Arial"/>
-              </a:defRPr>
-            </a:pPr>
-            <a:r>
-              <a:rPr lang="en-US" sz="1725" dirty="0">
-                <a:solidFill>
-                  <a:srgbClr val="202020"/>
-                </a:solidFill>
-                <a:latin typeface="Arial"/>
-                <a:ea typeface="Arial"/>
-                <a:cs typeface="Arial"/>
-              </a:rPr>
-              <a:t>Converts the command name to lowercase</a:t>
-            </a:r>
-          </a:p>
-          <a:p>
-            <a:pPr marL="742950" lvl="1" indent="-285750">
-              <a:buFont typeface="Arial" panose="020B0604020202020204" pitchFamily="34" charset="0"/>
-              <a:buChar char="•"/>
-              <a:defRPr sz="1725" b="0">
-                <a:solidFill>
-                  <a:srgbClr val="202020"/>
-                </a:solidFill>
-                <a:latin typeface="Arial"/>
-                <a:ea typeface="Arial"/>
-                <a:cs typeface="Arial"/>
-              </a:defRPr>
-            </a:pPr>
-            <a:r>
-              <a:rPr lang="en-US" sz="1725" dirty="0">
-                <a:solidFill>
-                  <a:srgbClr val="202020"/>
-                </a:solidFill>
-                <a:latin typeface="Arial"/>
-                <a:ea typeface="Arial"/>
-                <a:cs typeface="Arial"/>
-              </a:rPr>
-              <a:t>Separates the command from its argument</a:t>
-            </a:r>
-          </a:p>
-          <a:p>
-            <a:pPr marL="742950" lvl="1" indent="-285750">
-              <a:buFont typeface="Arial" panose="020B0604020202020204" pitchFamily="34" charset="0"/>
-              <a:buChar char="•"/>
-              <a:defRPr sz="1725" b="0">
-                <a:solidFill>
-                  <a:srgbClr val="202020"/>
-                </a:solidFill>
-                <a:latin typeface="Arial"/>
-                <a:ea typeface="Arial"/>
-                <a:cs typeface="Arial"/>
-              </a:defRPr>
-            </a:pPr>
-            <a:r>
-              <a:rPr lang="en-US" sz="1725" dirty="0">
-                <a:solidFill>
-                  <a:srgbClr val="202020"/>
-                </a:solidFill>
-                <a:latin typeface="Arial"/>
-                <a:ea typeface="Arial"/>
-                <a:cs typeface="Arial"/>
-              </a:rPr>
-              <a:t>Executes commands such as </a:t>
-            </a:r>
-            <a:r>
-              <a:rPr lang="en-US" sz="1725" b="1" i="1" dirty="0">
-                <a:solidFill>
-                  <a:srgbClr val="202020"/>
-                </a:solidFill>
-                <a:latin typeface="Arial"/>
-                <a:ea typeface="Arial"/>
-                <a:cs typeface="Arial"/>
-              </a:rPr>
-              <a:t>help, </a:t>
-            </a:r>
-            <a:r>
-              <a:rPr lang="en-US" sz="1725" b="1" i="1" dirty="0" err="1">
-                <a:solidFill>
-                  <a:srgbClr val="202020"/>
-                </a:solidFill>
-                <a:latin typeface="Arial"/>
-                <a:ea typeface="Arial"/>
-                <a:cs typeface="Arial"/>
-              </a:rPr>
-              <a:t>start_marquee</a:t>
-            </a:r>
-            <a:r>
-              <a:rPr lang="en-US" sz="1725" b="1" i="1" dirty="0">
-                <a:solidFill>
-                  <a:srgbClr val="202020"/>
-                </a:solidFill>
-                <a:latin typeface="Arial"/>
-                <a:ea typeface="Arial"/>
-                <a:cs typeface="Arial"/>
-              </a:rPr>
-              <a:t>, </a:t>
-            </a:r>
-          </a:p>
-          <a:p>
-            <a:pPr lvl="1">
-              <a:defRPr sz="1725" b="0">
-                <a:solidFill>
-                  <a:srgbClr val="202020"/>
-                </a:solidFill>
-                <a:latin typeface="Arial"/>
-                <a:ea typeface="Arial"/>
-                <a:cs typeface="Arial"/>
-              </a:defRPr>
-            </a:pPr>
-            <a:r>
-              <a:rPr lang="en-US" sz="1725" b="1" i="1" dirty="0">
-                <a:solidFill>
-                  <a:srgbClr val="202020"/>
-                </a:solidFill>
-                <a:latin typeface="Arial"/>
-                <a:ea typeface="Arial"/>
-                <a:cs typeface="Arial"/>
-              </a:rPr>
-              <a:t>     </a:t>
-            </a:r>
-            <a:r>
-              <a:rPr lang="en-US" sz="1725" b="1" i="1" dirty="0" err="1">
-                <a:solidFill>
-                  <a:srgbClr val="202020"/>
-                </a:solidFill>
-                <a:latin typeface="Arial"/>
-                <a:ea typeface="Arial"/>
-                <a:cs typeface="Arial"/>
-              </a:rPr>
-              <a:t>stop_marquee</a:t>
-            </a:r>
-            <a:r>
-              <a:rPr lang="en-US" sz="1725" b="1" i="1" dirty="0">
-                <a:solidFill>
-                  <a:srgbClr val="202020"/>
-                </a:solidFill>
-                <a:latin typeface="Arial"/>
-                <a:ea typeface="Arial"/>
-                <a:cs typeface="Arial"/>
-              </a:rPr>
-              <a:t>, </a:t>
-            </a:r>
-            <a:r>
-              <a:rPr lang="en-US" sz="1725" b="1" i="1" dirty="0" err="1">
-                <a:solidFill>
-                  <a:srgbClr val="202020"/>
-                </a:solidFill>
-                <a:latin typeface="Arial"/>
-                <a:ea typeface="Arial"/>
-                <a:cs typeface="Arial"/>
-              </a:rPr>
-              <a:t>set_text</a:t>
-            </a:r>
-            <a:r>
-              <a:rPr lang="en-US" sz="1725" b="1" i="1" dirty="0">
-                <a:solidFill>
-                  <a:srgbClr val="202020"/>
-                </a:solidFill>
-                <a:latin typeface="Arial"/>
-                <a:ea typeface="Arial"/>
-                <a:cs typeface="Arial"/>
-              </a:rPr>
-              <a:t>, </a:t>
-            </a:r>
-            <a:r>
-              <a:rPr lang="en-US" sz="1725" b="1" i="1" dirty="0" err="1">
-                <a:solidFill>
-                  <a:srgbClr val="202020"/>
-                </a:solidFill>
-                <a:latin typeface="Arial"/>
-                <a:ea typeface="Arial"/>
-                <a:cs typeface="Arial"/>
-              </a:rPr>
-              <a:t>set_speed</a:t>
-            </a:r>
-            <a:r>
-              <a:rPr lang="en-US" sz="1725" b="1" i="1" dirty="0">
-                <a:solidFill>
-                  <a:srgbClr val="202020"/>
-                </a:solidFill>
-                <a:latin typeface="Arial"/>
-                <a:ea typeface="Arial"/>
-                <a:cs typeface="Arial"/>
-              </a:rPr>
-              <a:t>, exit </a:t>
-            </a:r>
-          </a:p>
-          <a:p>
-            <a:pPr marL="285750" indent="-285750">
-              <a:buFont typeface="Arial" panose="020B0604020202020204" pitchFamily="34" charset="0"/>
-              <a:buChar char="•"/>
-              <a:defRPr sz="1725" b="0">
-                <a:solidFill>
-                  <a:srgbClr val="202020"/>
-                </a:solidFill>
-                <a:latin typeface="Arial"/>
-                <a:ea typeface="Arial"/>
-                <a:cs typeface="Arial"/>
-              </a:defRPr>
-            </a:pPr>
-            <a:r>
-              <a:rPr lang="en-US" sz="1725" dirty="0">
-                <a:solidFill>
-                  <a:srgbClr val="202020"/>
-                </a:solidFill>
-                <a:latin typeface="Arial"/>
-                <a:ea typeface="Arial"/>
-                <a:cs typeface="Arial"/>
-              </a:rPr>
-              <a:t>Invalid commands display an error message.</a:t>
-            </a:r>
-          </a:p>
-          <a:p>
-            <a:pPr marL="285750" indent="-285750">
-              <a:buFont typeface="Arial" panose="020B0604020202020204" pitchFamily="34" charset="0"/>
-              <a:buChar char="•"/>
-              <a:defRPr sz="1725" b="0">
-                <a:solidFill>
-                  <a:srgbClr val="202020"/>
-                </a:solidFill>
-                <a:latin typeface="Arial"/>
-                <a:ea typeface="Arial"/>
-                <a:cs typeface="Arial"/>
-              </a:defRPr>
-            </a:pPr>
-            <a:r>
-              <a:rPr lang="en-US" sz="1725" b="1" i="1" dirty="0" err="1">
-                <a:solidFill>
-                  <a:srgbClr val="202020"/>
-                </a:solidFill>
-                <a:latin typeface="Arial"/>
-                <a:ea typeface="Arial"/>
-                <a:cs typeface="Arial"/>
-              </a:rPr>
-              <a:t>set_speed</a:t>
-            </a:r>
-            <a:r>
-              <a:rPr lang="en-US" sz="1725" b="1" i="1" dirty="0">
-                <a:solidFill>
-                  <a:srgbClr val="202020"/>
-                </a:solidFill>
-                <a:latin typeface="Arial"/>
-                <a:ea typeface="Arial"/>
-                <a:cs typeface="Arial"/>
-              </a:rPr>
               <a:t> </a:t>
             </a:r>
             <a:r>
@@ -2967,7 +2401,7 @@
                 <a:ea typeface="Arial"/>
                 <a:cs typeface="Arial"/>
               </a:rPr>
-              <a:t>validates values from 1 to 60000 milliseconds.</a:t>
+              <a:t>only accepts 1–60000.</a:t>
             </a:r>
             <a:endParaRPr sz="1725" dirty="0">
               <a:solidFill>
@@ -2982,10 +2416,10 @@
       </p:sp>
       <p:pic>
         <p:nvPicPr>
-          <p:cNvPr id="4" name="Picture 3">
+          <p:cNvPr id="5" name="Picture 4">
             <a:extLst>
               <a:ext uri="{FF2B5EF4-FFF2-40B4-BE49-F238E27FC236}">
-                <a16:creationId xmlns:a16="http://schemas.microsoft.com/office/drawing/2014/main" id="{1B433DAB-16F2-C476-1D70-1238D9DD418D}"/>
+                <a16:creationId xmlns:a16="http://schemas.microsoft.com/office/drawing/2014/main" id="{05C6912F-D6B6-733C-DC62-F5ABBCAE0105}"/>
               </a:ext>
             </a:extLst>
           </p:cNvPr>
@@ -3002,8 +2436,8 @@
         </p:blipFill>
         <p:spPr>
           <a:xfrm>
-            <a:off x="7705397" y="2276475"/>
-            <a:ext cx="3800803" cy="3246840"/>
+            <a:off x="3264558" y="3429541"/>
+            <a:ext cx="5662883" cy="2793843"/>
           </a:xfrm>
           <a:prstGeom prst="rect">
             <a:avLst/>
@@ -3127,8 +2561,8 @@
         </p:nvSpPr>
         <p:spPr>
           <a:xfrm>
-            <a:off x="685800" y="1707832"/>
-            <a:ext cx="5696712" cy="885825"/>
+            <a:off x="685800" y="1351216"/>
+            <a:ext cx="10820400" cy="885825"/>
           </a:xfrm>
           <a:prstGeom prst="rect">
             <a:avLst/>
@@ -3144,7 +2578,7 @@
           </a:bodyPr>
           <a:lstStyle/>
           <a:p>
-            <a:pPr marL="285750" indent="-285750">
+            <a:pPr marL="285750" indent="-285750" algn="just">
               <a:buFont typeface="Arial" panose="020B0604020202020204" pitchFamily="34" charset="0"/>
               <a:buChar char="•"/>
               <a:defRPr sz="1725" b="0">
@@ -3187,11 +2621,11 @@
                 <a:ea typeface="Arial"/>
                 <a:cs typeface="Arial"/>
               </a:rPr>
-              <a:t>creates a blank 2D text buffer using the current console width and height.</a:t>
-            </a:r>
-          </a:p>
-          <a:p>
-            <a:pPr marL="285750" indent="-285750">
+              <a:t>creates a blank text grid the size of the console on every redraw.</a:t>
+            </a:r>
+          </a:p>
+          <a:p>
+            <a:pPr marL="285750" indent="-285750" algn="just">
               <a:buFont typeface="Arial" panose="020B0604020202020204" pitchFamily="34" charset="0"/>
               <a:buChar char="•"/>
               <a:defRPr sz="1725" b="0">
@@ -3204,19 +2638,41 @@
               </a:defRPr>
             </a:pPr>
             <a:r>
-              <a:rPr lang="en-US" sz="1725" dirty="0">
-                <a:solidFill>
-                  <a:srgbClr val="202020"/>
-                </a:solidFill>
-                <a:latin typeface="Arial"/>
-                <a:ea typeface="Arial"/>
-                <a:cs typeface="Arial"/>
-              </a:rPr>
-              <a:t>The header, title, version date, marquee art, separators, status, prompt, and command output are placed into the buffer.</a:t>
-            </a:r>
-          </a:p>
-          <a:p>
-            <a:pPr marL="285750" indent="-285750">
+              <a:rPr lang="en-US" sz="1725" b="1" i="1" dirty="0" err="1">
+                <a:solidFill>
+                  <a:srgbClr val="202020"/>
+                </a:solidFill>
+                <a:latin typeface="Arial"/>
+                <a:ea typeface="Arial"/>
+                <a:cs typeface="Arial"/>
+              </a:rPr>
+              <a:t>putStr</a:t>
+            </a:r>
+            <a:r>
+              <a:rPr lang="en-US" sz="1725" b="1" i="1" dirty="0">
+                <a:solidFill>
+                  <a:srgbClr val="202020"/>
+                </a:solidFill>
+                <a:latin typeface="Arial"/>
+                <a:ea typeface="Arial"/>
+                <a:cs typeface="Arial"/>
+              </a:rPr>
+              <a:t>() </a:t>
+            </a:r>
+            <a:r>
+              <a:rPr lang="en-US" sz="1725" dirty="0">
+                <a:solidFill>
+                  <a:srgbClr val="202020"/>
+                </a:solidFill>
+                <a:latin typeface="Arial"/>
+                <a:ea typeface="Arial"/>
+                <a:cs typeface="Arial"/>
+              </a:rPr>
+              <a:t>writes text at a given row and column, cut off at the grid edges.</a:t>
+            </a:r>
+          </a:p>
+          <a:p>
+            <a:pPr marL="285750" indent="-285750" algn="just">
               <a:buFont typeface="Arial" panose="020B0604020202020204" pitchFamily="34" charset="0"/>
               <a:buChar char="•"/>
               <a:defRPr sz="1725" b="0">
@@ -3229,41 +2685,19 @@
               </a:defRPr>
             </a:pPr>
             <a:r>
-              <a:rPr lang="en-US" sz="1725" b="1" i="1" dirty="0" err="1">
-                <a:solidFill>
-                  <a:srgbClr val="202020"/>
-                </a:solidFill>
-                <a:latin typeface="Arial"/>
-                <a:ea typeface="Arial"/>
-                <a:cs typeface="Arial"/>
-              </a:rPr>
-              <a:t>putStr</a:t>
-            </a:r>
-            <a:r>
-              <a:rPr lang="en-US" sz="1725" b="1" i="1" dirty="0">
-                <a:solidFill>
-                  <a:srgbClr val="202020"/>
-                </a:solidFill>
-                <a:latin typeface="Arial"/>
-                <a:ea typeface="Arial"/>
-                <a:cs typeface="Arial"/>
-              </a:rPr>
-              <a:t>() </a:t>
-            </a:r>
-            <a:r>
-              <a:rPr lang="en-US" sz="1725" dirty="0">
-                <a:solidFill>
-                  <a:srgbClr val="202020"/>
-                </a:solidFill>
-                <a:latin typeface="Arial"/>
-                <a:ea typeface="Arial"/>
-                <a:cs typeface="Arial"/>
-              </a:rPr>
-              <a:t>writes each piece of text at a specific row and column.</a:t>
-            </a:r>
-          </a:p>
-          <a:p>
-            <a:pPr marL="285750" indent="-285750">
+              <a:rPr lang="en-US" sz="1725" dirty="0">
+                <a:solidFill>
+                  <a:srgbClr val="202020"/>
+                </a:solidFill>
+                <a:latin typeface="Arial"/>
+                <a:ea typeface="Arial"/>
+                <a:cs typeface="Arial"/>
+              </a:rPr>
+              <a:t>Drawing order: header, marquee art at (x, y) with spaces left transparent, separator, status, prompt with input and  _ , output.</a:t>
+            </a:r>
+          </a:p>
+          <a:p>
+            <a:pPr marL="285750" indent="-285750" algn="just">
               <a:buFont typeface="Arial" panose="020B0604020202020204" pitchFamily="34" charset="0"/>
               <a:buChar char="•"/>
               <a:defRPr sz="1725" b="0">
@@ -3284,11 +2718,11 @@
                 <a:ea typeface="Arial"/>
                 <a:cs typeface="Arial"/>
               </a:rPr>
-              <a:t>The marquee art is drawn using its current x and y position.</a:t>
-            </a:r>
-          </a:p>
-          <a:p>
-            <a:pPr marL="285750" indent="-285750">
+              <a:t>The output area sizes itself to the message (1–7 lines), and the marquee gets the remaining rows.</a:t>
+            </a:r>
+          </a:p>
+          <a:p>
+            <a:pPr marL="285750" indent="-285750" algn="just">
               <a:buFont typeface="Arial" panose="020B0604020202020204" pitchFamily="34" charset="0"/>
               <a:buChar char="•"/>
               <a:defRPr sz="1725" b="0">
@@ -3309,22 +2743,8 @@
                 <a:ea typeface="Arial"/>
                 <a:cs typeface="Arial"/>
               </a:rPr>
-              <a:t>All rows are combined into one complete frame.</a:t>
-            </a:r>
-          </a:p>
-          <a:p>
-            <a:pPr marL="285750" indent="-285750">
-              <a:buFont typeface="Arial" panose="020B0604020202020204" pitchFamily="34" charset="0"/>
-              <a:buChar char="•"/>
-              <a:defRPr sz="1725" b="0">
-                <a:solidFill>
-                  <a:srgbClr val="202020"/>
-                </a:solidFill>
-                <a:latin typeface="Arial"/>
-                <a:ea typeface="Arial"/>
-                <a:cs typeface="Arial"/>
-              </a:defRPr>
-            </a:pPr>
+              <a:t>All rows are joined into one string. </a:t>
+            </a:r>
             <a:r>
               <a:rPr lang="en-US" sz="1725" b="1" i="1" dirty="0" err="1">
                 <a:solidFill>
@@ -3356,7 +2776,7 @@
                 <a:ea typeface="Arial"/>
                 <a:cs typeface="Arial"/>
               </a:rPr>
-              <a:t>prints the frame from the top-left corner, replacing the previous display instead of scrolling.</a:t>
+              <a:t>moves the cursor to (0,0) and overwrites the screen, so nothing scrolls.</a:t>
             </a:r>
             <a:endParaRPr sz="1725" dirty="0">
               <a:solidFill>
@@ -3371,10 +2791,10 @@
       </p:sp>
       <p:pic>
         <p:nvPicPr>
-          <p:cNvPr id="5" name="Picture 4">
+          <p:cNvPr id="4" name="Picture 3">
             <a:extLst>
               <a:ext uri="{FF2B5EF4-FFF2-40B4-BE49-F238E27FC236}">
-                <a16:creationId xmlns:a16="http://schemas.microsoft.com/office/drawing/2014/main" id="{42025C8C-DBE8-EE10-0E6A-2FB228E31229}"/>
+                <a16:creationId xmlns:a16="http://schemas.microsoft.com/office/drawing/2014/main" id="{970B7A5F-42B8-EB28-C09A-8A8178162280}"/>
               </a:ext>
             </a:extLst>
           </p:cNvPr>
@@ -3391,8 +2811,8 @@
         </p:blipFill>
         <p:spPr>
           <a:xfrm>
-            <a:off x="7337815" y="1707832"/>
-            <a:ext cx="4168385" cy="3442335"/>
+            <a:off x="3518225" y="3554449"/>
+            <a:ext cx="5155550" cy="2478205"/>
           </a:xfrm>
           <a:prstGeom prst="rect">
             <a:avLst/>
@@ -3516,8 +2936,8 @@
         </p:nvSpPr>
         <p:spPr>
           <a:xfrm>
-            <a:off x="685800" y="1707832"/>
-            <a:ext cx="6766560" cy="885825"/>
+            <a:off x="685800" y="1296352"/>
+            <a:ext cx="10820400" cy="885825"/>
           </a:xfrm>
           <a:prstGeom prst="rect">
             <a:avLst/>
@@ -3533,7 +2953,7 @@
           </a:bodyPr>
           <a:lstStyle/>
           <a:p>
-            <a:pPr marL="285750" indent="-285750">
+            <a:pPr marL="285750" indent="-285750" algn="just">
               <a:buFont typeface="Arial" panose="020B0604020202020204" pitchFamily="34" charset="0"/>
               <a:buChar char="•"/>
               <a:defRPr sz="1725" b="0">
@@ -3546,17 +2966,6 @@
               </a:defRPr>
             </a:pPr>
             <a:r>
-              <a:rPr lang="en-US" sz="1725" dirty="0">
-                <a:solidFill>
-                  <a:srgbClr val="202020"/>
-                </a:solidFill>
-                <a:latin typeface="Arial"/>
-                <a:ea typeface="Arial"/>
-                <a:cs typeface="Arial"/>
-              </a:rPr>
-              <a:t>The marquee position is stored in </a:t>
-            </a:r>
-            <a:r>
               <a:rPr lang="en-US" sz="1725" b="1" i="1" dirty="0" err="1">
                 <a:solidFill>
                   <a:srgbClr val="202020"/>
@@ -3576,11 +2985,55 @@
                 <a:ea typeface="Arial"/>
                 <a:cs typeface="Arial"/>
               </a:rPr>
-              <a:t> using x and y.</a:t>
-            </a:r>
-          </a:p>
-          <a:p>
-            <a:pPr marL="285750" indent="-285750">
+              <a:t> stores the position (x, y) and the direction (</a:t>
+            </a:r>
+            <a:r>
+              <a:rPr lang="en-US" sz="1725" dirty="0" err="1">
+                <a:solidFill>
+                  <a:srgbClr val="202020"/>
+                </a:solidFill>
+                <a:latin typeface="Arial"/>
+                <a:ea typeface="Arial"/>
+                <a:cs typeface="Arial"/>
+              </a:rPr>
+              <a:t>vx</a:t>
+            </a:r>
+            <a:r>
+              <a:rPr lang="en-US" sz="1725" dirty="0">
+                <a:solidFill>
+                  <a:srgbClr val="202020"/>
+                </a:solidFill>
+                <a:latin typeface="Arial"/>
+                <a:ea typeface="Arial"/>
+                <a:cs typeface="Arial"/>
+              </a:rPr>
+              <a:t>, </a:t>
+            </a:r>
+            <a:r>
+              <a:rPr lang="en-US" sz="1725" dirty="0" err="1">
+                <a:solidFill>
+                  <a:srgbClr val="202020"/>
+                </a:solidFill>
+                <a:latin typeface="Arial"/>
+                <a:ea typeface="Arial"/>
+                <a:cs typeface="Arial"/>
+              </a:rPr>
+              <a:t>vy</a:t>
+            </a:r>
+            <a:r>
+              <a:rPr lang="en-US" sz="1725" dirty="0">
+                <a:solidFill>
+                  <a:srgbClr val="202020"/>
+                </a:solidFill>
+                <a:latin typeface="Arial"/>
+                <a:ea typeface="Arial"/>
+                <a:cs typeface="Arial"/>
+              </a:rPr>
+              <a:t>, each +1 or −1).</a:t>
+            </a:r>
+          </a:p>
+          <a:p>
+            <a:pPr marL="285750" indent="-285750" algn="just">
               <a:buFont typeface="Arial" panose="020B0604020202020204" pitchFamily="34" charset="0"/>
               <a:buChar char="•"/>
               <a:defRPr sz="1725" b="0">
@@ -3593,6 +3046,17 @@
               </a:defRPr>
             </a:pPr>
             <a:r>
+              <a:rPr lang="en-US" sz="1725" dirty="0">
+                <a:solidFill>
+                  <a:srgbClr val="202020"/>
+                </a:solidFill>
+                <a:latin typeface="Arial"/>
+                <a:ea typeface="Arial"/>
+                <a:cs typeface="Arial"/>
+              </a:rPr>
+              <a:t>The art moves one cell per redraw, so its speed is set by the refresh interval ( </a:t>
+            </a:r>
+            <a:r>
               <a:rPr lang="en-US" sz="1725" b="1" i="1" dirty="0" err="1">
                 <a:solidFill>
                   <a:srgbClr val="202020"/>
@@ -3601,29 +3065,7 @@
                 <a:ea typeface="Arial"/>
                 <a:cs typeface="Arial"/>
               </a:rPr>
-              <a:t>vx</a:t>
-            </a:r>
-            <a:r>
-              <a:rPr lang="en-US" sz="1725" dirty="0">
-                <a:solidFill>
-                  <a:srgbClr val="202020"/>
-                </a:solidFill>
-                <a:latin typeface="Arial"/>
-                <a:ea typeface="Arial"/>
-                <a:cs typeface="Arial"/>
-              </a:rPr>
-              <a:t> and </a:t>
-            </a:r>
-            <a:r>
-              <a:rPr lang="en-US" sz="1725" b="1" i="1" dirty="0" err="1">
-                <a:solidFill>
-                  <a:srgbClr val="202020"/>
-                </a:solidFill>
-                <a:latin typeface="Arial"/>
-                <a:ea typeface="Arial"/>
-                <a:cs typeface="Arial"/>
-              </a:rPr>
-              <a:t>vy</a:t>
+              <a:t>set_speed</a:t>
             </a:r>
             <a:r>
               <a:rPr lang="en-US" sz="1725" b="1" i="1" dirty="0">
@@ -3645,11 +3087,11 @@
                 <a:ea typeface="Arial"/>
                 <a:cs typeface="Arial"/>
               </a:rPr>
-              <a:t>store the horizontal and vertical movement directions.</a:t>
-            </a:r>
-          </a:p>
-          <a:p>
-            <a:pPr marL="285750" indent="-285750">
+              <a:t>).</a:t>
+            </a:r>
+          </a:p>
+          <a:p>
+            <a:pPr marL="285750" indent="-285750" algn="just">
               <a:buFont typeface="Arial" panose="020B0604020202020204" pitchFamily="34" charset="0"/>
               <a:buChar char="•"/>
               <a:defRPr sz="1725" b="0">
@@ -3662,41 +3104,85 @@
               </a:defRPr>
             </a:pPr>
             <a:r>
-              <a:rPr lang="en-US" sz="1725" b="1" i="1" dirty="0" err="1">
-                <a:solidFill>
-                  <a:srgbClr val="202020"/>
-                </a:solidFill>
-                <a:latin typeface="Arial"/>
-                <a:ea typeface="Arial"/>
-                <a:cs typeface="Arial"/>
-              </a:rPr>
-              <a:t>updateMotion</a:t>
-            </a:r>
-            <a:r>
-              <a:rPr lang="en-US" sz="1725" b="1" i="1" dirty="0">
-                <a:solidFill>
-                  <a:srgbClr val="202020"/>
-                </a:solidFill>
-                <a:latin typeface="Arial"/>
-                <a:ea typeface="Arial"/>
-                <a:cs typeface="Arial"/>
-              </a:rPr>
-              <a:t>() </a:t>
-            </a:r>
-            <a:r>
-              <a:rPr lang="en-US" sz="1725" dirty="0">
-                <a:solidFill>
-                  <a:srgbClr val="202020"/>
-                </a:solidFill>
-                <a:latin typeface="Arial"/>
-                <a:ea typeface="Arial"/>
-                <a:cs typeface="Arial"/>
-              </a:rPr>
-              <a:t>calculates the available animation boundaries based on:</a:t>
-            </a:r>
-          </a:p>
-          <a:p>
-            <a:pPr marL="742950" lvl="1" indent="-285750">
+              <a:rPr lang="en-US" sz="1725" dirty="0">
+                <a:solidFill>
+                  <a:srgbClr val="202020"/>
+                </a:solidFill>
+                <a:latin typeface="Arial"/>
+                <a:ea typeface="Arial"/>
+                <a:cs typeface="Arial"/>
+              </a:rPr>
+              <a:t>Bounds: x goes from 0 to </a:t>
+            </a:r>
+            <a:r>
+              <a:rPr lang="en-US" sz="1725" dirty="0" err="1">
+                <a:solidFill>
+                  <a:srgbClr val="202020"/>
+                </a:solidFill>
+                <a:latin typeface="Arial"/>
+                <a:ea typeface="Arial"/>
+                <a:cs typeface="Arial"/>
+              </a:rPr>
+              <a:t>consoleW</a:t>
+            </a:r>
+            <a:r>
+              <a:rPr lang="en-US" sz="1725" dirty="0">
+                <a:solidFill>
+                  <a:srgbClr val="202020"/>
+                </a:solidFill>
+                <a:latin typeface="Arial"/>
+                <a:ea typeface="Arial"/>
+                <a:cs typeface="Arial"/>
+              </a:rPr>
+              <a:t> − art width, and y from </a:t>
+            </a:r>
+            <a:r>
+              <a:rPr lang="en-US" sz="1725" dirty="0" err="1">
+                <a:solidFill>
+                  <a:srgbClr val="202020"/>
+                </a:solidFill>
+                <a:latin typeface="Arial"/>
+                <a:ea typeface="Arial"/>
+                <a:cs typeface="Arial"/>
+              </a:rPr>
+              <a:t>marqueeTop</a:t>
+            </a:r>
+            <a:r>
+              <a:rPr lang="en-US" sz="1725" dirty="0">
+                <a:solidFill>
+                  <a:srgbClr val="202020"/>
+                </a:solidFill>
+                <a:latin typeface="Arial"/>
+                <a:ea typeface="Arial"/>
+                <a:cs typeface="Arial"/>
+              </a:rPr>
+              <a:t> to </a:t>
+            </a:r>
+            <a:r>
+              <a:rPr lang="en-US" sz="1725" dirty="0" err="1">
+                <a:solidFill>
+                  <a:srgbClr val="202020"/>
+                </a:solidFill>
+                <a:latin typeface="Arial"/>
+                <a:ea typeface="Arial"/>
+                <a:cs typeface="Arial"/>
+              </a:rPr>
+              <a:t>marqueeBottom</a:t>
+            </a:r>
+            <a:r>
+              <a:rPr lang="en-US" sz="1725" dirty="0">
+                <a:solidFill>
+                  <a:srgbClr val="202020"/>
+                </a:solidFill>
+                <a:latin typeface="Arial"/>
+                <a:ea typeface="Arial"/>
+                <a:cs typeface="Arial"/>
+              </a:rPr>
+              <a:t> − art height + 1.</a:t>
+            </a:r>
+          </a:p>
+          <a:p>
+            <a:pPr marL="285750" indent="-285750" algn="just">
               <a:buFont typeface="Arial" panose="020B0604020202020204" pitchFamily="34" charset="0"/>
               <a:buChar char="•"/>
               <a:defRPr sz="1725" b="0">
@@ -3717,11 +3203,11 @@
                 <a:ea typeface="Arial"/>
                 <a:cs typeface="Arial"/>
               </a:rPr>
-              <a:t>Console width</a:t>
-            </a:r>
-          </a:p>
-          <a:p>
-            <a:pPr marL="742950" lvl="1" indent="-285750">
+              <a:t>At an edge, the direction flips and the position is pulled back inside, so the art bounces.</a:t>
+            </a:r>
+          </a:p>
+          <a:p>
+            <a:pPr marL="285750" indent="-285750" algn="just">
               <a:buFont typeface="Arial" panose="020B0604020202020204" pitchFamily="34" charset="0"/>
               <a:buChar char="•"/>
               <a:defRPr sz="1725" b="0">
@@ -3742,11 +3228,11 @@
                 <a:ea typeface="Arial"/>
                 <a:cs typeface="Arial"/>
               </a:rPr>
-              <a:t>Console height</a:t>
-            </a:r>
-          </a:p>
-          <a:p>
-            <a:pPr marL="742950" lvl="1" indent="-285750">
+              <a:t>After a resize or an output change, the art is pulled back inside the marquee area.</a:t>
+            </a:r>
+          </a:p>
+          <a:p>
+            <a:pPr marL="285750" indent="-285750" algn="just">
               <a:buFont typeface="Arial" panose="020B0604020202020204" pitchFamily="34" charset="0"/>
               <a:buChar char="•"/>
               <a:defRPr sz="1725" b="0">
@@ -3759,115 +3245,15 @@
               </a:defRPr>
             </a:pPr>
             <a:r>
-              <a:rPr lang="en-US" sz="1725" dirty="0">
-                <a:solidFill>
-                  <a:srgbClr val="202020"/>
-                </a:solidFill>
-                <a:latin typeface="Arial"/>
-                <a:ea typeface="Arial"/>
-                <a:cs typeface="Arial"/>
-              </a:rPr>
-              <a:t>Marquee artwork size</a:t>
-            </a:r>
-          </a:p>
-          <a:p>
-            <a:pPr marL="742950" lvl="1" indent="-285750">
-              <a:buFont typeface="Arial" panose="020B0604020202020204" pitchFamily="34" charset="0"/>
-              <a:buChar char="•"/>
-              <a:defRPr sz="1725" b="0">
-                <a:solidFill>
-                  <a:srgbClr val="202020"/>
-                </a:solidFill>
-                <a:latin typeface="Arial"/>
-                <a:ea typeface="Arial"/>
-                <a:cs typeface="Arial"/>
-              </a:defRPr>
-            </a:pPr>
-            <a:r>
-              <a:rPr lang="en-US" sz="1725" dirty="0">
-                <a:solidFill>
-                  <a:srgbClr val="202020"/>
-                </a:solidFill>
-                <a:latin typeface="Arial"/>
-                <a:ea typeface="Arial"/>
-                <a:cs typeface="Arial"/>
-              </a:rPr>
-              <a:t>Header and bottom separator positions</a:t>
-            </a:r>
-          </a:p>
-          <a:p>
-            <a:pPr marL="285750" indent="-285750">
-              <a:buFont typeface="Arial" panose="020B0604020202020204" pitchFamily="34" charset="0"/>
-              <a:buChar char="•"/>
-              <a:defRPr sz="1725" b="0">
-                <a:solidFill>
-                  <a:srgbClr val="202020"/>
-                </a:solidFill>
-                <a:latin typeface="Arial"/>
-                <a:ea typeface="Arial"/>
-                <a:cs typeface="Arial"/>
-              </a:defRPr>
-            </a:pPr>
-            <a:r>
-              <a:rPr lang="en-US" sz="1725" dirty="0">
-                <a:solidFill>
-                  <a:srgbClr val="202020"/>
-                </a:solidFill>
-                <a:latin typeface="Arial"/>
-                <a:ea typeface="Arial"/>
-                <a:cs typeface="Arial"/>
-              </a:rPr>
-              <a:t>The marquee moves one character at a time.</a:t>
-            </a:r>
-          </a:p>
-          <a:p>
-            <a:pPr marL="285750" indent="-285750">
-              <a:buFont typeface="Arial" panose="020B0604020202020204" pitchFamily="34" charset="0"/>
-              <a:buChar char="•"/>
-              <a:defRPr sz="1725" b="0">
-                <a:solidFill>
-                  <a:srgbClr val="202020"/>
-                </a:solidFill>
-                <a:latin typeface="Arial"/>
-                <a:ea typeface="Arial"/>
-                <a:cs typeface="Arial"/>
-              </a:defRPr>
-            </a:pPr>
-            <a:r>
-              <a:rPr lang="en-US" sz="1725" dirty="0">
-                <a:solidFill>
-                  <a:srgbClr val="202020"/>
-                </a:solidFill>
-                <a:latin typeface="Arial"/>
-                <a:ea typeface="Arial"/>
-                <a:cs typeface="Arial"/>
-              </a:rPr>
-              <a:t>The direction reverses when the artwork reaches an edge.</a:t>
-            </a:r>
-          </a:p>
-          <a:p>
-            <a:pPr marL="285750" indent="-285750">
-              <a:buFont typeface="Arial" panose="020B0604020202020204" pitchFamily="34" charset="0"/>
-              <a:buChar char="•"/>
-              <a:defRPr sz="1725" b="0">
-                <a:solidFill>
-                  <a:srgbClr val="202020"/>
-                </a:solidFill>
-                <a:latin typeface="Arial"/>
-                <a:ea typeface="Arial"/>
-                <a:cs typeface="Arial"/>
-              </a:defRPr>
-            </a:pPr>
-            <a:r>
-              <a:rPr lang="en-US" sz="1725" dirty="0">
-                <a:solidFill>
-                  <a:srgbClr val="202020"/>
-                </a:solidFill>
-                <a:latin typeface="Arial"/>
-                <a:ea typeface="Arial"/>
-                <a:cs typeface="Arial"/>
-              </a:rPr>
-              <a:t>The animation updates once every 10 rendered frames using </a:t>
+              <a:rPr lang="en-US" sz="1725" b="1" i="1" dirty="0" err="1">
+                <a:solidFill>
+                  <a:srgbClr val="202020"/>
+                </a:solidFill>
+                <a:latin typeface="Arial"/>
+                <a:ea typeface="Arial"/>
+                <a:cs typeface="Arial"/>
+              </a:rPr>
+              <a:t>stop_marquee</a:t>
             </a:r>
             <a:r>
               <a:rPr lang="en-US" sz="1725" b="1" i="1" dirty="0">
@@ -3878,33 +3264,19 @@
                 <a:ea typeface="Arial"/>
                 <a:cs typeface="Arial"/>
               </a:rPr>
-              <a:t>ANIM_STEP</a:t>
-            </a:r>
-            <a:r>
-              <a:rPr lang="en-US" sz="1725" dirty="0">
-                <a:solidFill>
-                  <a:srgbClr val="202020"/>
-                </a:solidFill>
-                <a:latin typeface="Arial"/>
-                <a:ea typeface="Arial"/>
-                <a:cs typeface="Arial"/>
-              </a:rPr>
-              <a:t>.</a:t>
-            </a:r>
-          </a:p>
-          <a:p>
-            <a:pPr marL="285750" indent="-285750">
-              <a:buFont typeface="Arial" panose="020B0604020202020204" pitchFamily="34" charset="0"/>
-              <a:buChar char="•"/>
-              <a:defRPr sz="1725" b="0">
-                <a:solidFill>
-                  <a:srgbClr val="202020"/>
-                </a:solidFill>
-                <a:latin typeface="Arial"/>
-                <a:ea typeface="Arial"/>
-                <a:cs typeface="Arial"/>
-              </a:defRPr>
-            </a:pPr>
+              <a:t> </a:t>
+            </a:r>
+            <a:r>
+              <a:rPr lang="en-US" sz="1725" dirty="0">
+                <a:solidFill>
+                  <a:srgbClr val="202020"/>
+                </a:solidFill>
+                <a:latin typeface="Arial"/>
+                <a:ea typeface="Arial"/>
+                <a:cs typeface="Arial"/>
+              </a:rPr>
+              <a:t>only pauses movement; the screen keeps refreshing. </a:t>
+            </a:r>
             <a:r>
               <a:rPr lang="en-US" sz="1725" b="1" i="1" dirty="0" err="1">
                 <a:solidFill>
@@ -3914,7 +3286,7 @@
                 <a:ea typeface="Arial"/>
                 <a:cs typeface="Arial"/>
               </a:rPr>
-              <a:t>start_marquee</a:t>
+              <a:t>set_text</a:t>
             </a:r>
             <a:r>
               <a:rPr lang="en-US" sz="1725" b="1" i="1" dirty="0">
@@ -3925,87 +3297,18 @@
                 <a:ea typeface="Arial"/>
                 <a:cs typeface="Arial"/>
               </a:rPr>
-              <a:t> </a:t>
-            </a:r>
-            <a:r>
-              <a:rPr lang="en-US" sz="1725" dirty="0">
-                <a:solidFill>
-                  <a:srgbClr val="202020"/>
-                </a:solidFill>
-                <a:latin typeface="Arial"/>
-                <a:ea typeface="Arial"/>
-                <a:cs typeface="Arial"/>
-              </a:rPr>
-              <a:t>resumes movement, while </a:t>
-            </a:r>
-            <a:r>
-              <a:rPr lang="en-US" sz="1725" b="1" i="1" dirty="0" err="1">
-                <a:solidFill>
-                  <a:srgbClr val="202020"/>
-                </a:solidFill>
-                <a:latin typeface="Arial"/>
-                <a:ea typeface="Arial"/>
-                <a:cs typeface="Arial"/>
-              </a:rPr>
-              <a:t>stop_marquee</a:t>
-            </a:r>
-            <a:r>
-              <a:rPr lang="en-US" sz="1725" b="1" i="1" dirty="0">
-                <a:solidFill>
-                  <a:srgbClr val="202020"/>
-                </a:solidFill>
-                <a:latin typeface="Arial"/>
-                <a:ea typeface="Arial"/>
-                <a:cs typeface="Arial"/>
-              </a:rPr>
-              <a:t> </a:t>
-            </a:r>
-            <a:r>
-              <a:rPr lang="en-US" sz="1725" dirty="0">
-                <a:solidFill>
-                  <a:srgbClr val="202020"/>
-                </a:solidFill>
-                <a:latin typeface="Arial"/>
-                <a:ea typeface="Arial"/>
-                <a:cs typeface="Arial"/>
-              </a:rPr>
-              <a:t>pauses it.</a:t>
-            </a:r>
-          </a:p>
-          <a:p>
-            <a:pPr marL="285750" indent="-285750">
-              <a:buFont typeface="Arial" panose="020B0604020202020204" pitchFamily="34" charset="0"/>
-              <a:buChar char="•"/>
-              <a:defRPr sz="1725" b="0">
-                <a:solidFill>
-                  <a:srgbClr val="202020"/>
-                </a:solidFill>
-                <a:latin typeface="Arial"/>
-                <a:ea typeface="Arial"/>
-                <a:cs typeface="Arial"/>
-              </a:defRPr>
-            </a:pPr>
-            <a:r>
-              <a:rPr lang="en-US" sz="1725" b="1" i="1" dirty="0" err="1">
-                <a:solidFill>
-                  <a:srgbClr val="202020"/>
-                </a:solidFill>
-                <a:latin typeface="Arial"/>
-                <a:ea typeface="Arial"/>
-                <a:cs typeface="Arial"/>
-              </a:rPr>
-              <a:t>set_text</a:t>
-            </a:r>
-            <a:r>
-              <a:rPr lang="en-US" sz="1725" dirty="0">
-                <a:solidFill>
-                  <a:srgbClr val="202020"/>
-                </a:solidFill>
-                <a:latin typeface="Arial"/>
-                <a:ea typeface="Arial"/>
-                <a:cs typeface="Arial"/>
-              </a:rPr>
-              <a:t> replaces the artwork and resets its starting position.</a:t>
+              <a:t> </a:t>
+            </a:r>
+            <a:r>
+              <a:rPr lang="en-US" sz="1725" dirty="0">
+                <a:solidFill>
+                  <a:srgbClr val="202020"/>
+                </a:solidFill>
+                <a:latin typeface="Arial"/>
+                <a:ea typeface="Arial"/>
+                <a:cs typeface="Arial"/>
+              </a:rPr>
+              <a:t>replaces the art and restarts it near the top-left.</a:t>
             </a:r>
             <a:endParaRPr sz="1725" dirty="0">
               <a:solidFill>
@@ -4020,10 +3323,10 @@
       </p:sp>
       <p:pic>
         <p:nvPicPr>
-          <p:cNvPr id="4" name="Picture 3">
+          <p:cNvPr id="5" name="Picture 4">
             <a:extLst>
               <a:ext uri="{FF2B5EF4-FFF2-40B4-BE49-F238E27FC236}">
-                <a16:creationId xmlns:a16="http://schemas.microsoft.com/office/drawing/2014/main" id="{0094C58C-D6F5-1956-C01B-B4E8FB7729D4}"/>
+                <a16:creationId xmlns:a16="http://schemas.microsoft.com/office/drawing/2014/main" id="{81099BE4-EFA0-FACB-7A2A-86BEA09F3711}"/>
               </a:ext>
             </a:extLst>
           </p:cNvPr>
@@ -4040,8 +3343,8 @@
         </p:blipFill>
         <p:spPr>
           <a:xfrm>
-            <a:off x="7790932" y="1771944"/>
-            <a:ext cx="3715268" cy="3972479"/>
+            <a:off x="1614825" y="3748184"/>
+            <a:ext cx="8962350" cy="1981008"/>
           </a:xfrm>
           <a:prstGeom prst="rect">
             <a:avLst/>
@@ -4165,8 +3468,8 @@
         </p:nvSpPr>
         <p:spPr>
           <a:xfrm>
-            <a:off x="685800" y="1442656"/>
-            <a:ext cx="6766560" cy="885825"/>
+            <a:off x="685800" y="1162050"/>
+            <a:ext cx="10820400" cy="885825"/>
           </a:xfrm>
           <a:prstGeom prst="rect">
             <a:avLst/>
@@ -4195,15 +3498,37 @@
               </a:defRPr>
             </a:pPr>
             <a:r>
-              <a:rPr lang="en-US" sz="1725" dirty="0">
-                <a:solidFill>
-                  <a:srgbClr val="202020"/>
-                </a:solidFill>
-                <a:latin typeface="Arial"/>
-                <a:ea typeface="Arial"/>
-                <a:cs typeface="Arial"/>
-              </a:rPr>
-              <a:t>The monitor refresh rate is targeted at 165 Hz.</a:t>
+              <a:rPr lang="en-US" sz="1725" b="1" i="1" dirty="0" err="1">
+                <a:solidFill>
+                  <a:srgbClr val="202020"/>
+                </a:solidFill>
+                <a:latin typeface="Arial"/>
+                <a:ea typeface="Arial"/>
+                <a:cs typeface="Arial"/>
+              </a:rPr>
+              <a:t>set_speed</a:t>
+            </a:r>
+            <a:r>
+              <a:rPr lang="en-US" sz="1725" b="1" i="1" dirty="0">
+                <a:solidFill>
+                  <a:srgbClr val="202020"/>
+                </a:solidFill>
+                <a:latin typeface="Arial"/>
+                <a:ea typeface="Arial"/>
+                <a:cs typeface="Arial"/>
+              </a:rPr>
+              <a:t> </a:t>
+            </a:r>
+            <a:r>
+              <a:rPr lang="en-US" sz="1725" dirty="0">
+                <a:solidFill>
+                  <a:srgbClr val="202020"/>
+                </a:solidFill>
+                <a:latin typeface="Arial"/>
+                <a:ea typeface="Arial"/>
+                <a:cs typeface="Arial"/>
+              </a:rPr>
+              <a:t>changes both the redraw rate and the marquee speed.</a:t>
             </a:r>
           </a:p>
           <a:p>
@@ -4228,7 +3553,29 @@
                 <a:ea typeface="Arial"/>
                 <a:cs typeface="Arial"/>
               </a:rPr>
-              <a:t>The default redraw interval is 6 </a:t>
+              <a:t>Measured on this PC (Ryzen 5 5600G): </a:t>
+            </a:r>
+            <a:r>
+              <a:rPr lang="en-US" sz="1725" b="1" i="1" dirty="0">
+                <a:solidFill>
+                  <a:srgbClr val="202020"/>
+                </a:solidFill>
+                <a:latin typeface="Arial"/>
+                <a:ea typeface="Arial"/>
+                <a:cs typeface="Arial"/>
+              </a:rPr>
+              <a:t>Sleep(1) </a:t>
+            </a:r>
+            <a:r>
+              <a:rPr lang="en-US" sz="1725" dirty="0">
+                <a:solidFill>
+                  <a:srgbClr val="202020"/>
+                </a:solidFill>
+                <a:latin typeface="Arial"/>
+                <a:ea typeface="Arial"/>
+                <a:cs typeface="Arial"/>
+              </a:rPr>
+              <a:t>actually takes about 15.8 </a:t>
             </a:r>
             <a:r>
               <a:rPr lang="en-US" sz="1725" dirty="0" err="1">
@@ -4250,54 +3597,7 @@
                 <a:ea typeface="Arial"/>
                 <a:cs typeface="Arial"/>
               </a:rPr>
-              <a:t>, calculated from </a:t>
-            </a:r>
-            <a:r>
-              <a:rPr lang="en-US" sz="1725" b="1" i="1" dirty="0">
-                <a:solidFill>
-                  <a:srgbClr val="202020"/>
-                </a:solidFill>
-                <a:latin typeface="Arial"/>
-                <a:ea typeface="Arial"/>
-                <a:cs typeface="Arial"/>
-              </a:rPr>
-              <a:t>1000 / 165</a:t>
-            </a:r>
-            <a:r>
-              <a:rPr lang="en-US" sz="1725" dirty="0">
-                <a:solidFill>
-                  <a:srgbClr val="202020"/>
-                </a:solidFill>
-                <a:latin typeface="Arial"/>
-                <a:ea typeface="Arial"/>
-                <a:cs typeface="Arial"/>
-              </a:rPr>
-              <a:t>.</a:t>
-            </a:r>
-          </a:p>
-          <a:p>
-            <a:pPr marL="285750" indent="-285750">
-              <a:buFont typeface="Arial" panose="020B0604020202020204" pitchFamily="34" charset="0"/>
-              <a:buChar char="•"/>
-              <a:defRPr sz="1725" b="0">
-                <a:solidFill>
-                  <a:srgbClr val="202020"/>
-                </a:solidFill>
-                <a:latin typeface="Arial"/>
-                <a:ea typeface="Arial"/>
-                <a:cs typeface="Arial"/>
-              </a:defRPr>
-            </a:pPr>
-            <a:r>
-              <a:rPr lang="en-US" sz="1725" dirty="0">
-                <a:solidFill>
-                  <a:srgbClr val="202020"/>
-                </a:solidFill>
-                <a:latin typeface="Arial"/>
-                <a:ea typeface="Arial"/>
-                <a:cs typeface="Arial"/>
-              </a:rPr>
-              <a:t>Keyboard input is polled every 1 </a:t>
+              <a:t> (Windows' default timer), so the loop only runs about 63 times a second. That gives about 63 FPS at 6 </a:t>
             </a:r>
             <a:r>
               <a:rPr lang="en-US" sz="1725" dirty="0" err="1">
@@ -4319,220 +3619,7 @@
                 <a:ea typeface="Arial"/>
                 <a:cs typeface="Arial"/>
               </a:rPr>
-              <a:t> to reduce typing delay.</a:t>
-            </a:r>
-          </a:p>
-          <a:p>
-            <a:pPr marL="285750" indent="-285750">
-              <a:buFont typeface="Arial" panose="020B0604020202020204" pitchFamily="34" charset="0"/>
-              <a:buChar char="•"/>
-              <a:defRPr sz="1725" b="0">
-                <a:solidFill>
-                  <a:srgbClr val="202020"/>
-                </a:solidFill>
-                <a:latin typeface="Arial"/>
-                <a:ea typeface="Arial"/>
-                <a:cs typeface="Arial"/>
-              </a:defRPr>
-            </a:pPr>
-            <a:r>
-              <a:rPr lang="en-US" sz="1725" b="1" i="1" dirty="0">
-                <a:solidFill>
-                  <a:srgbClr val="202020"/>
-                </a:solidFill>
-                <a:latin typeface="Arial"/>
-                <a:ea typeface="Arial"/>
-                <a:cs typeface="Arial"/>
-              </a:rPr>
-              <a:t>BASE_SLEEP_MS = 1 </a:t>
-            </a:r>
-            <a:r>
-              <a:rPr lang="en-US" sz="1725" dirty="0">
-                <a:solidFill>
-                  <a:srgbClr val="202020"/>
-                </a:solidFill>
-                <a:latin typeface="Arial"/>
-                <a:ea typeface="Arial"/>
-                <a:cs typeface="Arial"/>
-              </a:rPr>
-              <a:t>prevents the main loop from using excessive CPU.</a:t>
-            </a:r>
-          </a:p>
-          <a:p>
-            <a:pPr marL="285750" indent="-285750">
-              <a:buFont typeface="Arial" panose="020B0604020202020204" pitchFamily="34" charset="0"/>
-              <a:buChar char="•"/>
-              <a:defRPr sz="1725" b="0">
-                <a:solidFill>
-                  <a:srgbClr val="202020"/>
-                </a:solidFill>
-                <a:latin typeface="Arial"/>
-                <a:ea typeface="Arial"/>
-                <a:cs typeface="Arial"/>
-              </a:defRPr>
-            </a:pPr>
-            <a:r>
-              <a:rPr lang="en-US" sz="1725" dirty="0">
-                <a:solidFill>
-                  <a:srgbClr val="202020"/>
-                </a:solidFill>
-                <a:latin typeface="Arial"/>
-                <a:ea typeface="Arial"/>
-                <a:cs typeface="Arial"/>
-              </a:rPr>
-              <a:t>The </a:t>
-            </a:r>
-            <a:r>
-              <a:rPr lang="en-US" sz="1725" b="1" i="1" dirty="0" err="1">
-                <a:solidFill>
-                  <a:srgbClr val="202020"/>
-                </a:solidFill>
-                <a:latin typeface="Arial"/>
-                <a:ea typeface="Arial"/>
-                <a:cs typeface="Arial"/>
-              </a:rPr>
-              <a:t>set_speed</a:t>
-            </a:r>
-            <a:r>
-              <a:rPr lang="en-US" sz="1725" b="1" i="1" dirty="0">
-                <a:solidFill>
-                  <a:srgbClr val="202020"/>
-                </a:solidFill>
-                <a:latin typeface="Arial"/>
-                <a:ea typeface="Arial"/>
-                <a:cs typeface="Arial"/>
-              </a:rPr>
-              <a:t> </a:t>
-            </a:r>
-            <a:r>
-              <a:rPr lang="en-US" sz="1725" dirty="0">
-                <a:solidFill>
-                  <a:srgbClr val="202020"/>
-                </a:solidFill>
-                <a:latin typeface="Arial"/>
-                <a:ea typeface="Arial"/>
-                <a:cs typeface="Arial"/>
-              </a:rPr>
-              <a:t>command allows different redraw intervals to be tested.</a:t>
-            </a:r>
-          </a:p>
-          <a:p>
-            <a:pPr marL="285750" indent="-285750">
-              <a:buFont typeface="Arial" panose="020B0604020202020204" pitchFamily="34" charset="0"/>
-              <a:buChar char="•"/>
-              <a:defRPr sz="1725" b="0">
-                <a:solidFill>
-                  <a:srgbClr val="202020"/>
-                </a:solidFill>
-                <a:latin typeface="Arial"/>
-                <a:ea typeface="Arial"/>
-                <a:cs typeface="Arial"/>
-              </a:defRPr>
-            </a:pPr>
-            <a:r>
-              <a:rPr lang="en-US" sz="1725" dirty="0">
-                <a:solidFill>
-                  <a:srgbClr val="202020"/>
-                </a:solidFill>
-                <a:latin typeface="Arial"/>
-                <a:ea typeface="Arial"/>
-                <a:cs typeface="Arial"/>
-              </a:rPr>
-              <a:t>Test values such as </a:t>
-            </a:r>
-            <a:r>
-              <a:rPr lang="en-US" sz="1725" b="1" i="1" dirty="0">
-                <a:solidFill>
-                  <a:srgbClr val="202020"/>
-                </a:solidFill>
-                <a:latin typeface="Arial"/>
-                <a:ea typeface="Arial"/>
-                <a:cs typeface="Arial"/>
-              </a:rPr>
-              <a:t>1, 2, 4, 6, 8, 10, </a:t>
-            </a:r>
-            <a:r>
-              <a:rPr lang="en-US" sz="1725" dirty="0">
-                <a:solidFill>
-                  <a:srgbClr val="202020"/>
-                </a:solidFill>
-                <a:latin typeface="Arial"/>
-                <a:ea typeface="Arial"/>
-                <a:cs typeface="Arial"/>
-              </a:rPr>
-              <a:t>and </a:t>
-            </a:r>
-            <a:r>
-              <a:rPr lang="en-US" sz="1725" b="1" i="1" dirty="0">
-                <a:solidFill>
-                  <a:srgbClr val="202020"/>
-                </a:solidFill>
-                <a:latin typeface="Arial"/>
-                <a:ea typeface="Arial"/>
-                <a:cs typeface="Arial"/>
-              </a:rPr>
-              <a:t>16</a:t>
-            </a:r>
-            <a:r>
-              <a:rPr lang="en-US" sz="1725" dirty="0">
-                <a:solidFill>
-                  <a:srgbClr val="202020"/>
-                </a:solidFill>
-                <a:latin typeface="Arial"/>
-                <a:ea typeface="Arial"/>
-                <a:cs typeface="Arial"/>
-              </a:rPr>
-              <a:t> milliseconds.</a:t>
-            </a:r>
-          </a:p>
-          <a:p>
-            <a:pPr marL="285750" indent="-285750">
-              <a:buFont typeface="Arial" panose="020B0604020202020204" pitchFamily="34" charset="0"/>
-              <a:buChar char="•"/>
-              <a:defRPr sz="1725" b="0">
-                <a:solidFill>
-                  <a:srgbClr val="202020"/>
-                </a:solidFill>
-                <a:latin typeface="Arial"/>
-                <a:ea typeface="Arial"/>
-                <a:cs typeface="Arial"/>
-              </a:defRPr>
-            </a:pPr>
-            <a:r>
-              <a:rPr lang="en-US" sz="1725" dirty="0">
-                <a:solidFill>
-                  <a:srgbClr val="202020"/>
-                </a:solidFill>
-                <a:latin typeface="Arial"/>
-                <a:ea typeface="Arial"/>
-                <a:cs typeface="Arial"/>
-              </a:rPr>
-              <a:t>The recommended setting is:</a:t>
-            </a:r>
-          </a:p>
-          <a:p>
-            <a:pPr marL="742950" lvl="1" indent="-285750">
-              <a:buFont typeface="Arial" panose="020B0604020202020204" pitchFamily="34" charset="0"/>
-              <a:buChar char="•"/>
-              <a:defRPr sz="1725" b="0">
-                <a:solidFill>
-                  <a:srgbClr val="202020"/>
-                </a:solidFill>
-                <a:latin typeface="Arial"/>
-                <a:ea typeface="Arial"/>
-                <a:cs typeface="Arial"/>
-              </a:defRPr>
-            </a:pPr>
-            <a:r>
-              <a:rPr lang="en-US" sz="1725" dirty="0">
-                <a:solidFill>
-                  <a:srgbClr val="202020"/>
-                </a:solidFill>
-                <a:latin typeface="Arial"/>
-                <a:ea typeface="Arial"/>
-                <a:cs typeface="Arial"/>
-              </a:rPr>
-              <a:t>6 </a:t>
+              <a:t>, and input is really polled about every 16 </a:t>
             </a:r>
             <a:r>
               <a:rPr lang="en-US" sz="1725" dirty="0" err="1">
@@ -4543,142 +3630,9 @@
                 <a:ea typeface="Arial"/>
                 <a:cs typeface="Arial"/>
               </a:rPr>
-              <a:t>ms</a:t>
-            </a:r>
-            <a:r>
-              <a:rPr lang="en-US" sz="1725" dirty="0">
-                <a:solidFill>
-                  <a:srgbClr val="202020"/>
-                </a:solidFill>
-                <a:latin typeface="Arial"/>
-                <a:ea typeface="Arial"/>
-                <a:cs typeface="Arial"/>
-              </a:rPr>
-              <a:t> refresh interval</a:t>
-            </a:r>
-          </a:p>
-          <a:p>
-            <a:pPr marL="742950" lvl="1" indent="-285750">
-              <a:buFont typeface="Arial" panose="020B0604020202020204" pitchFamily="34" charset="0"/>
-              <a:buChar char="•"/>
-              <a:defRPr sz="1725" b="0">
-                <a:solidFill>
-                  <a:srgbClr val="202020"/>
-                </a:solidFill>
-                <a:latin typeface="Arial"/>
-                <a:ea typeface="Arial"/>
-                <a:cs typeface="Arial"/>
-              </a:defRPr>
-            </a:pPr>
-            <a:r>
-              <a:rPr lang="en-US" sz="1725" dirty="0">
-                <a:solidFill>
-                  <a:srgbClr val="202020"/>
-                </a:solidFill>
-                <a:latin typeface="Arial"/>
-                <a:ea typeface="Arial"/>
-                <a:cs typeface="Arial"/>
-              </a:rPr>
-              <a:t>1 </a:t>
-            </a:r>
-            <a:r>
-              <a:rPr lang="en-US" sz="1725" dirty="0" err="1">
-                <a:solidFill>
-                  <a:srgbClr val="202020"/>
-                </a:solidFill>
-                <a:latin typeface="Arial"/>
-                <a:ea typeface="Arial"/>
-                <a:cs typeface="Arial"/>
-              </a:rPr>
-              <a:t>ms</a:t>
-            </a:r>
-            <a:r>
-              <a:rPr lang="en-US" sz="1725" dirty="0">
-                <a:solidFill>
-                  <a:srgbClr val="202020"/>
-                </a:solidFill>
-                <a:latin typeface="Arial"/>
-                <a:ea typeface="Arial"/>
-                <a:cs typeface="Arial"/>
-              </a:rPr>
-              <a:t> polling interval</a:t>
-            </a:r>
-          </a:p>
-          <a:p>
-            <a:pPr marL="285750" indent="-285750">
-              <a:buFont typeface="Arial" panose="020B0604020202020204" pitchFamily="34" charset="0"/>
-              <a:buChar char="•"/>
-              <a:defRPr sz="1725" b="0">
-                <a:solidFill>
-                  <a:srgbClr val="202020"/>
-                </a:solidFill>
-                <a:latin typeface="Arial"/>
-                <a:ea typeface="Arial"/>
-                <a:cs typeface="Arial"/>
-              </a:defRPr>
-            </a:pPr>
-            <a:r>
-              <a:rPr lang="en-US" sz="1725" dirty="0">
-                <a:solidFill>
-                  <a:srgbClr val="202020"/>
-                </a:solidFill>
-                <a:latin typeface="Arial"/>
-                <a:ea typeface="Arial"/>
-                <a:cs typeface="Arial"/>
-              </a:rPr>
-              <a:t>The refresh limit is the fastest setting before screen tearing, stuttering, or excessive CPU usage appears.</a:t>
-            </a:r>
-          </a:p>
-          <a:p>
-            <a:pPr marL="285750" indent="-285750">
-              <a:buFont typeface="Arial" panose="020B0604020202020204" pitchFamily="34" charset="0"/>
-              <a:buChar char="•"/>
-              <a:defRPr sz="1725" b="0">
-                <a:solidFill>
-                  <a:srgbClr val="202020"/>
-                </a:solidFill>
-                <a:latin typeface="Arial"/>
-                <a:ea typeface="Arial"/>
-                <a:cs typeface="Arial"/>
-              </a:defRPr>
-            </a:pPr>
-            <a:r>
-              <a:rPr lang="en-US" sz="1725" dirty="0">
-                <a:solidFill>
-                  <a:srgbClr val="202020"/>
-                </a:solidFill>
-                <a:latin typeface="Arial"/>
-                <a:ea typeface="Arial"/>
-                <a:cs typeface="Arial"/>
-              </a:rPr>
-              <a:t>The polling limit is the slowest setting, where typing still feels responsive.</a:t>
-            </a:r>
-          </a:p>
-          <a:p>
-            <a:pPr marL="285750" indent="-285750">
-              <a:buFont typeface="Arial" panose="020B0604020202020204" pitchFamily="34" charset="0"/>
-              <a:buChar char="•"/>
-              <a:defRPr sz="1725" b="0">
-                <a:solidFill>
-                  <a:srgbClr val="202020"/>
-                </a:solidFill>
-                <a:latin typeface="Arial"/>
-                <a:ea typeface="Arial"/>
-                <a:cs typeface="Arial"/>
-              </a:defRPr>
-            </a:pPr>
-            <a:r>
-              <a:rPr lang="en-US" sz="1725" dirty="0">
-                <a:solidFill>
-                  <a:srgbClr val="202020"/>
-                </a:solidFill>
-                <a:latin typeface="Arial"/>
-                <a:ea typeface="Arial"/>
-                <a:cs typeface="Arial"/>
-              </a:rPr>
-              <a:t>Exact limits depend on the monitor, terminal, and computer hardware.</a:t>
-            </a:r>
-            <a:endParaRPr sz="1725" dirty="0">
+              <a:t>ms.</a:t>
+            </a:r>
+            <a:endParaRPr lang="en-US" sz="1725" dirty="0">
               <a:solidFill>
                 <a:srgbClr val="202020"/>
               </a:solidFill>
@@ -4687,14 +3641,240 @@
               <a:cs typeface="Arial"/>
             </a:endParaRPr>
           </a:p>
+          <a:p>
+            <a:pPr marL="285750" indent="-285750">
+              <a:buFont typeface="Arial" panose="020B0604020202020204" pitchFamily="34" charset="0"/>
+              <a:buChar char="•"/>
+              <a:defRPr sz="1725" b="0">
+                <a:solidFill>
+                  <a:srgbClr val="202020"/>
+                </a:solidFill>
+                <a:latin typeface="Arial"/>
+                <a:ea typeface="Arial"/>
+                <a:cs typeface="Arial"/>
+              </a:defRPr>
+            </a:pPr>
+            <a:r>
+              <a:rPr lang="en-US" sz="1725" dirty="0">
+                <a:solidFill>
+                  <a:srgbClr val="202020"/>
+                </a:solidFill>
+                <a:latin typeface="Arial"/>
+                <a:ea typeface="Arial"/>
+                <a:cs typeface="Arial"/>
+              </a:rPr>
+              <a:t>Measured </a:t>
+            </a:r>
+            <a:r>
+              <a:rPr lang="en-US" sz="1725" b="1" i="1" dirty="0" err="1">
+                <a:solidFill>
+                  <a:srgbClr val="202020"/>
+                </a:solidFill>
+                <a:latin typeface="Arial"/>
+                <a:ea typeface="Arial"/>
+                <a:cs typeface="Arial"/>
+              </a:rPr>
+              <a:t>set_speed</a:t>
+            </a:r>
+            <a:r>
+              <a:rPr lang="en-US" sz="1725" b="1" i="1" dirty="0">
+                <a:solidFill>
+                  <a:srgbClr val="202020"/>
+                </a:solidFill>
+                <a:latin typeface="Arial"/>
+                <a:ea typeface="Arial"/>
+                <a:cs typeface="Arial"/>
+              </a:rPr>
+              <a:t> </a:t>
+            </a:r>
+            <a:r>
+              <a:rPr lang="en-US" sz="1725" dirty="0">
+                <a:solidFill>
+                  <a:srgbClr val="202020"/>
+                </a:solidFill>
+                <a:latin typeface="Arial"/>
+                <a:ea typeface="Arial"/>
+                <a:cs typeface="Arial"/>
+              </a:rPr>
+              <a:t>results: 1–15 </a:t>
+            </a:r>
+            <a:r>
+              <a:rPr lang="en-US" sz="1725" dirty="0" err="1">
+                <a:solidFill>
+                  <a:srgbClr val="202020"/>
+                </a:solidFill>
+                <a:latin typeface="Arial"/>
+                <a:ea typeface="Arial"/>
+                <a:cs typeface="Arial"/>
+              </a:rPr>
+              <a:t>ms</a:t>
+            </a:r>
+            <a:r>
+              <a:rPr lang="en-US" sz="1725" dirty="0">
+                <a:solidFill>
+                  <a:srgbClr val="202020"/>
+                </a:solidFill>
+                <a:latin typeface="Arial"/>
+                <a:ea typeface="Arial"/>
+                <a:cs typeface="Arial"/>
+              </a:rPr>
+              <a:t> all give about 63 FPS, 16 gives about 52, 17 about 31, and 33 about 21.</a:t>
+            </a:r>
+          </a:p>
+          <a:p>
+            <a:pPr marL="285750" indent="-285750">
+              <a:buFont typeface="Arial" panose="020B0604020202020204" pitchFamily="34" charset="0"/>
+              <a:buChar char="•"/>
+              <a:defRPr sz="1725" b="0">
+                <a:solidFill>
+                  <a:srgbClr val="202020"/>
+                </a:solidFill>
+                <a:latin typeface="Arial"/>
+                <a:ea typeface="Arial"/>
+                <a:cs typeface="Arial"/>
+              </a:defRPr>
+            </a:pPr>
+            <a:r>
+              <a:rPr lang="en-US" sz="1725" dirty="0">
+                <a:solidFill>
+                  <a:srgbClr val="202020"/>
+                </a:solidFill>
+                <a:latin typeface="Arial"/>
+                <a:ea typeface="Arial"/>
+                <a:cs typeface="Arial"/>
+              </a:rPr>
+              <a:t>Recommended for this PC: keep the 6 </a:t>
+            </a:r>
+            <a:r>
+              <a:rPr lang="en-US" sz="1725" dirty="0" err="1">
+                <a:solidFill>
+                  <a:srgbClr val="202020"/>
+                </a:solidFill>
+                <a:latin typeface="Arial"/>
+                <a:ea typeface="Arial"/>
+                <a:cs typeface="Arial"/>
+              </a:rPr>
+              <a:t>ms</a:t>
+            </a:r>
+            <a:r>
+              <a:rPr lang="en-US" sz="1725" dirty="0">
+                <a:solidFill>
+                  <a:srgbClr val="202020"/>
+                </a:solidFill>
+                <a:latin typeface="Arial"/>
+                <a:ea typeface="Arial"/>
+                <a:cs typeface="Arial"/>
+              </a:rPr>
+              <a:t> refresh (any value up to 15 </a:t>
+            </a:r>
+            <a:r>
+              <a:rPr lang="en-US" sz="1725" dirty="0" err="1">
+                <a:solidFill>
+                  <a:srgbClr val="202020"/>
+                </a:solidFill>
+                <a:latin typeface="Arial"/>
+                <a:ea typeface="Arial"/>
+                <a:cs typeface="Arial"/>
+              </a:rPr>
+              <a:t>ms</a:t>
+            </a:r>
+            <a:r>
+              <a:rPr lang="en-US" sz="1725" dirty="0">
+                <a:solidFill>
+                  <a:srgbClr val="202020"/>
+                </a:solidFill>
+                <a:latin typeface="Arial"/>
+                <a:ea typeface="Arial"/>
+                <a:cs typeface="Arial"/>
+              </a:rPr>
+              <a:t> reaches the maximum) and the 1 </a:t>
+            </a:r>
+            <a:r>
+              <a:rPr lang="en-US" sz="1725" dirty="0" err="1">
+                <a:solidFill>
+                  <a:srgbClr val="202020"/>
+                </a:solidFill>
+                <a:latin typeface="Arial"/>
+                <a:ea typeface="Arial"/>
+                <a:cs typeface="Arial"/>
+              </a:rPr>
+              <a:t>ms</a:t>
+            </a:r>
+            <a:r>
+              <a:rPr lang="en-US" sz="1725" dirty="0">
+                <a:solidFill>
+                  <a:srgbClr val="202020"/>
+                </a:solidFill>
+                <a:latin typeface="Arial"/>
+                <a:ea typeface="Arial"/>
+                <a:cs typeface="Arial"/>
+              </a:rPr>
+              <a:t> polling.</a:t>
+            </a:r>
+          </a:p>
+          <a:p>
+            <a:pPr marL="285750" indent="-285750">
+              <a:buFont typeface="Arial" panose="020B0604020202020204" pitchFamily="34" charset="0"/>
+              <a:buChar char="•"/>
+              <a:defRPr sz="1725" b="0">
+                <a:solidFill>
+                  <a:srgbClr val="202020"/>
+                </a:solidFill>
+                <a:latin typeface="Arial"/>
+                <a:ea typeface="Arial"/>
+                <a:cs typeface="Arial"/>
+              </a:defRPr>
+            </a:pPr>
+            <a:r>
+              <a:rPr lang="en-US" sz="1725" dirty="0">
+                <a:solidFill>
+                  <a:srgbClr val="202020"/>
+                </a:solidFill>
+                <a:latin typeface="Arial"/>
+                <a:ea typeface="Arial"/>
+                <a:cs typeface="Arial"/>
+              </a:rPr>
+              <a:t>Limits: No tearing or flicker even at 1 </a:t>
+            </a:r>
+            <a:r>
+              <a:rPr lang="en-US" sz="1725" dirty="0" err="1">
+                <a:solidFill>
+                  <a:srgbClr val="202020"/>
+                </a:solidFill>
+                <a:latin typeface="Arial"/>
+                <a:ea typeface="Arial"/>
+                <a:cs typeface="Arial"/>
+              </a:rPr>
+              <a:t>ms</a:t>
+            </a:r>
+            <a:r>
+              <a:rPr lang="en-US" sz="1725" dirty="0">
+                <a:solidFill>
+                  <a:srgbClr val="202020"/>
+                </a:solidFill>
+                <a:latin typeface="Arial"/>
+                <a:ea typeface="Arial"/>
+                <a:cs typeface="Arial"/>
+              </a:rPr>
+              <a:t> and typing lag noticeable at 500ms.</a:t>
+            </a:r>
+            <a:endParaRPr sz="1725" b="1" i="1" dirty="0">
+              <a:solidFill>
+                <a:srgbClr val="202020"/>
+              </a:solidFill>
+              <a:latin typeface="Arial"/>
+              <a:ea typeface="Arial"/>
+              <a:cs typeface="Arial"/>
+            </a:endParaRPr>
+          </a:p>
         </p:txBody>
       </p:sp>
       <p:pic>
         <p:nvPicPr>
-          <p:cNvPr id="5" name="Picture 4">
+          <p:cNvPr id="4" name="Picture 3">
             <a:extLst>
               <a:ext uri="{FF2B5EF4-FFF2-40B4-BE49-F238E27FC236}">
-                <a16:creationId xmlns:a16="http://schemas.microsoft.com/office/drawing/2014/main" id="{E8319136-F78A-0B6E-6B60-065E4A5DBC81}"/>
+                <a16:creationId xmlns:a16="http://schemas.microsoft.com/office/drawing/2014/main" id="{E5C4D78D-7B53-604D-7B52-09E53957873F}"/>
               </a:ext>
             </a:extLst>
           </p:cNvPr>
@@ -4711,8 +3891,8 @@
         </p:blipFill>
         <p:spPr>
           <a:xfrm>
-            <a:off x="7780049" y="2029968"/>
-            <a:ext cx="3726151" cy="3236291"/>
+            <a:off x="3246119" y="4035198"/>
+            <a:ext cx="5699761" cy="1876751"/>
           </a:xfrm>
           <a:prstGeom prst="rect">
             <a:avLst/>

</xml_diff>